<commit_message>
docs: add Data Visualization Certificate and update submission presentation
</commit_message>
<xml_diff>
--- a/VOIS_Major_Project_PPT_Submission_Completed.pptx
+++ b/VOIS_Major_Project_PPT_Submission_Completed.pptx
@@ -263,7 +263,7 @@
           <a:p>
             <a:fld id="{EF1077DB-935E-4A0A-947A-D283B9F9F452}" type="datetimeFigureOut">
               <a:rPr lang="en-US" smtClean="0"/>
-              <a:t>9/3/2026</a:t>
+              <a:t>9/10/2026</a:t>
             </a:fld>
             <a:endParaRPr lang="en-US" dirty="0"/>
           </a:p>
@@ -440,7 +440,7 @@
           <a:p>
             <a:fld id="{2D9EC30E-1A71-4188-9BE7-E2A64929A436}" type="datetimeFigureOut">
               <a:rPr lang="en-US" noProof="0" smtClean="0"/>
-              <a:t>9/3/2026</a:t>
+              <a:t>9/10/2026</a:t>
             </a:fld>
             <a:endParaRPr lang="en-US" noProof="0" dirty="0"/>
           </a:p>
@@ -1537,7 +1537,7 @@
             <a:fld id="{B61BEF0D-F0BB-DE4B-95CE-6DB70DBA9567}" type="datetimeFigureOut">
               <a:rPr lang="en-US" smtClean="0"/>
               <a:pPr/>
-              <a:t>9/3/2026</a:t>
+              <a:t>9/10/2026</a:t>
             </a:fld>
             <a:endParaRPr lang="en-US" dirty="0"/>
           </a:p>
@@ -1791,7 +1791,7 @@
             <a:fld id="{B61BEF0D-F0BB-DE4B-95CE-6DB70DBA9567}" type="datetimeFigureOut">
               <a:rPr lang="en-US" smtClean="0"/>
               <a:pPr/>
-              <a:t>9/3/2026</a:t>
+              <a:t>9/10/2026</a:t>
             </a:fld>
             <a:endParaRPr lang="en-US" dirty="0"/>
           </a:p>
@@ -2108,7 +2108,7 @@
             <a:fld id="{B61BEF0D-F0BB-DE4B-95CE-6DB70DBA9567}" type="datetimeFigureOut">
               <a:rPr lang="en-US" smtClean="0"/>
               <a:pPr/>
-              <a:t>9/3/2026</a:t>
+              <a:t>9/10/2026</a:t>
             </a:fld>
             <a:endParaRPr lang="en-US" dirty="0"/>
           </a:p>
@@ -2444,7 +2444,7 @@
             <a:fld id="{B61BEF0D-F0BB-DE4B-95CE-6DB70DBA9567}" type="datetimeFigureOut">
               <a:rPr lang="en-US" smtClean="0"/>
               <a:pPr/>
-              <a:t>9/3/2026</a:t>
+              <a:t>9/10/2026</a:t>
             </a:fld>
             <a:endParaRPr lang="en-US" dirty="0"/>
           </a:p>
@@ -2761,7 +2761,7 @@
             <a:fld id="{B61BEF0D-F0BB-DE4B-95CE-6DB70DBA9567}" type="datetimeFigureOut">
               <a:rPr lang="en-US" smtClean="0"/>
               <a:pPr/>
-              <a:t>9/3/2026</a:t>
+              <a:t>9/10/2026</a:t>
             </a:fld>
             <a:endParaRPr lang="en-US" dirty="0"/>
           </a:p>
@@ -3157,7 +3157,7 @@
             <a:fld id="{B61BEF0D-F0BB-DE4B-95CE-6DB70DBA9567}" type="datetimeFigureOut">
               <a:rPr lang="en-US" smtClean="0"/>
               <a:pPr/>
-              <a:t>9/3/2026</a:t>
+              <a:t>9/10/2026</a:t>
             </a:fld>
             <a:endParaRPr lang="en-US" dirty="0"/>
           </a:p>
@@ -3329,7 +3329,7 @@
           <a:p>
             <a:fld id="{55C6B4A9-1611-4792-9094-5F34BCA07E0B}" type="datetimeFigureOut">
               <a:rPr lang="en-US" smtClean="0"/>
-              <a:t>9/3/2026</a:t>
+              <a:t>9/10/2026</a:t>
             </a:fld>
             <a:endParaRPr lang="en-US" dirty="0"/>
           </a:p>
@@ -3511,7 +3511,7 @@
             <a:fld id="{B61BEF0D-F0BB-DE4B-95CE-6DB70DBA9567}" type="datetimeFigureOut">
               <a:rPr lang="en-US" smtClean="0"/>
               <a:pPr/>
-              <a:t>9/3/2026</a:t>
+              <a:t>9/10/2026</a:t>
             </a:fld>
             <a:endParaRPr lang="en-US" dirty="0"/>
           </a:p>
@@ -5240,7 +5240,7 @@
             <a:fld id="{B61BEF0D-F0BB-DE4B-95CE-6DB70DBA9567}" type="datetimeFigureOut">
               <a:rPr lang="en-US" smtClean="0"/>
               <a:pPr/>
-              <a:t>9/3/2026</a:t>
+              <a:t>9/10/2026</a:t>
             </a:fld>
             <a:endParaRPr lang="en-US" dirty="0"/>
           </a:p>
@@ -6975,7 +6975,7 @@
             <a:fld id="{B61BEF0D-F0BB-DE4B-95CE-6DB70DBA9567}" type="datetimeFigureOut">
               <a:rPr lang="en-US" smtClean="0"/>
               <a:pPr/>
-              <a:t>9/3/2026</a:t>
+              <a:t>9/10/2026</a:t>
             </a:fld>
             <a:endParaRPr lang="en-US" dirty="0"/>
           </a:p>
@@ -7209,7 +7209,7 @@
           <a:p>
             <a:fld id="{EB712588-04B1-427B-82EE-E8DB90309F08}" type="datetimeFigureOut">
               <a:rPr lang="en-US" smtClean="0"/>
-              <a:t>9/3/2026</a:t>
+              <a:t>9/10/2026</a:t>
             </a:fld>
             <a:endParaRPr lang="en-US" dirty="0"/>
           </a:p>
@@ -7585,7 +7585,7 @@
             <a:fld id="{B61BEF0D-F0BB-DE4B-95CE-6DB70DBA9567}" type="datetimeFigureOut">
               <a:rPr lang="en-US" smtClean="0"/>
               <a:pPr/>
-              <a:t>9/3/2026</a:t>
+              <a:t>9/10/2026</a:t>
             </a:fld>
             <a:endParaRPr lang="en-US" dirty="0"/>
           </a:p>
@@ -7711,7 +7711,7 @@
             <a:fld id="{B61BEF0D-F0BB-DE4B-95CE-6DB70DBA9567}" type="datetimeFigureOut">
               <a:rPr lang="en-US" smtClean="0"/>
               <a:pPr/>
-              <a:t>9/3/2026</a:t>
+              <a:t>9/10/2026</a:t>
             </a:fld>
             <a:endParaRPr lang="en-US" dirty="0"/>
           </a:p>
@@ -7809,7 +7809,7 @@
             <a:fld id="{B61BEF0D-F0BB-DE4B-95CE-6DB70DBA9567}" type="datetimeFigureOut">
               <a:rPr lang="en-US" smtClean="0"/>
               <a:pPr/>
-              <a:t>9/3/2026</a:t>
+              <a:t>9/10/2026</a:t>
             </a:fld>
             <a:endParaRPr lang="en-US" dirty="0"/>
           </a:p>
@@ -8066,7 +8066,7 @@
           <a:p>
             <a:fld id="{42A54C80-263E-416B-A8E0-580EDEADCBDC}" type="datetimeFigureOut">
               <a:rPr lang="en-US" smtClean="0"/>
-              <a:t>9/3/2026</a:t>
+              <a:t>9/10/2026</a:t>
             </a:fld>
             <a:endParaRPr lang="en-US" dirty="0"/>
           </a:p>
@@ -8374,7 +8374,7 @@
             <a:fld id="{B61BEF0D-F0BB-DE4B-95CE-6DB70DBA9567}" type="datetimeFigureOut">
               <a:rPr lang="en-US" smtClean="0"/>
               <a:pPr/>
-              <a:t>9/3/2026</a:t>
+              <a:t>9/10/2026</a:t>
             </a:fld>
             <a:endParaRPr lang="en-US" dirty="0"/>
           </a:p>
@@ -9078,7 +9078,7 @@
             <a:fld id="{B61BEF0D-F0BB-DE4B-95CE-6DB70DBA9567}" type="datetimeFigureOut">
               <a:rPr lang="en-US" smtClean="0"/>
               <a:pPr/>
-              <a:t>9/3/2026</a:t>
+              <a:t>9/10/2026</a:t>
             </a:fld>
             <a:endParaRPr lang="en-US" dirty="0"/>
           </a:p>
@@ -9289,7 +9289,7 @@
                 </a:solidFill>
               </a:rPr>
               <a:pPr/>
-              <a:t>9/3/2026</a:t>
+              <a:t>9/10/2026</a:t>
             </a:fld>
             <a:endParaRPr lang="en-US" sz="1100" dirty="0">
               <a:solidFill>
@@ -10042,42 +10042,78 @@
         </p:nvSpPr>
         <p:spPr>
           <a:xfrm>
-            <a:off x="-223157" y="3583914"/>
-            <a:ext cx="3400089" cy="861497"/>
+            <a:off x="675956" y="4044921"/>
+            <a:ext cx="4294877" cy="1139922"/>
           </a:xfrm>
         </p:spPr>
         <p:txBody>
           <a:bodyPr vert="horz" lIns="91440" tIns="45720" rIns="91440" bIns="45720" rtlCol="0" anchor="t">
-            <a:normAutofit/>
+            <a:noAutofit/>
           </a:bodyPr>
           <a:lstStyle/>
           <a:p>
-            <a:pPr algn="r">
-              <a:defRPr b="1" sz="1800">
+            <a:pPr algn="ctr">
+              <a:lnSpc>
+                <a:spcPct val="170000"/>
+              </a:lnSpc>
+              <a:defRPr sz="1800" b="1">
                 <a:solidFill>
                   <a:srgbClr val="102C57"/>
                 </a:solidFill>
               </a:defRPr>
             </a:pPr>
             <a:r>
-              <a:t>Student Name: Sathiyamoorthi K</a:t>
+              <a:rPr sz="1600" dirty="0">
+                <a:latin typeface="Times New Roman" panose="02020603050405020304" pitchFamily="18" charset="0"/>
+                <a:cs typeface="Times New Roman" panose="02020603050405020304" pitchFamily="18" charset="0"/>
+              </a:rPr>
+              <a:t>Student Name: </a:t>
             </a:r>
-            <a:endParaRPr lang="en-IN" b="0" dirty="0">
+            <a:r>
+              <a:rPr sz="1600" dirty="0">
+                <a:solidFill>
+                  <a:srgbClr val="FF0000"/>
+                </a:solidFill>
+                <a:latin typeface="Times New Roman" panose="02020603050405020304" pitchFamily="18" charset="0"/>
+                <a:cs typeface="Times New Roman" panose="02020603050405020304" pitchFamily="18" charset="0"/>
+              </a:rPr>
+              <a:t>Sathiyamoorthi K</a:t>
+            </a:r>
+            <a:endParaRPr lang="en-IN" sz="1600" dirty="0">
               <a:solidFill>
-                <a:schemeClr val="tx1"/>
+                <a:srgbClr val="FF0000"/>
               </a:solidFill>
+              <a:latin typeface="Times New Roman" panose="02020603050405020304" pitchFamily="18" charset="0"/>
+              <a:cs typeface="Times New Roman" panose="02020603050405020304" pitchFamily="18" charset="0"/>
             </a:endParaRPr>
           </a:p>
           <a:p>
-            <a:pPr>
-              <a:defRPr b="1" sz="1600">
-                <a:solidFill>
-                  <a:srgbClr val="282828"/>
+            <a:pPr algn="ctr">
+              <a:lnSpc>
+                <a:spcPct val="170000"/>
+              </a:lnSpc>
+              <a:defRPr sz="1800" b="1">
+                <a:solidFill>
+                  <a:srgbClr val="102C57"/>
                 </a:solidFill>
               </a:defRPr>
             </a:pPr>
             <a:r>
-              <a:t>College Name: IFET College of Engineering</a:t>
+              <a:rPr sz="1600" dirty="0">
+                <a:latin typeface="Times New Roman" panose="02020603050405020304" pitchFamily="18" charset="0"/>
+                <a:cs typeface="Times New Roman" panose="02020603050405020304" pitchFamily="18" charset="0"/>
+              </a:rPr>
+              <a:t>College Name: </a:t>
+            </a:r>
+            <a:r>
+              <a:rPr sz="1600" dirty="0">
+                <a:solidFill>
+                  <a:srgbClr val="FF0000"/>
+                </a:solidFill>
+                <a:latin typeface="Times New Roman" panose="02020603050405020304" pitchFamily="18" charset="0"/>
+                <a:cs typeface="Times New Roman" panose="02020603050405020304" pitchFamily="18" charset="0"/>
+              </a:rPr>
+              <a:t>IFET College of Engineering</a:t>
             </a:r>
           </a:p>
         </p:txBody>
@@ -10101,26 +10137,33 @@
         <p:spPr>
           <a:xfrm>
             <a:off x="678364" y="2844750"/>
-            <a:ext cx="4998720" cy="743448"/>
+            <a:ext cx="8913108" cy="1139922"/>
           </a:xfrm>
         </p:spPr>
         <p:txBody>
           <a:bodyPr>
-            <a:normAutofit/>
+            <a:noAutofit/>
           </a:bodyPr>
           <a:lstStyle/>
           <a:p>
-            <a:pPr>
-              <a:defRPr b="1" sz="2000">
+            <a:pPr algn="ctr">
+              <a:defRPr sz="2000" b="1">
                 <a:solidFill>
                   <a:srgbClr val="102C57"/>
                 </a:solidFill>
               </a:defRPr>
             </a:pPr>
             <a:r>
+              <a:rPr sz="3200" dirty="0">
+                <a:latin typeface="Times New Roman" panose="02020603050405020304" pitchFamily="18" charset="0"/>
+                <a:cs typeface="Times New Roman" panose="02020603050405020304" pitchFamily="18" charset="0"/>
+              </a:rPr>
               <a:t>Project Title: Seasonal Agriculture Performance Analysis &amp; Predictive Modeling</a:t>
             </a:r>
-            <a:endParaRPr lang="en-IN" sz="3200" dirty="0"/>
+            <a:endParaRPr lang="en-IN" sz="3200" dirty="0">
+              <a:latin typeface="Times New Roman" panose="02020603050405020304" pitchFamily="18" charset="0"/>
+              <a:cs typeface="Times New Roman" panose="02020603050405020304" pitchFamily="18" charset="0"/>
+            </a:endParaRPr>
           </a:p>
         </p:txBody>
       </p:sp>
@@ -10423,8 +10466,8 @@
         </p:nvSpPr>
         <p:spPr>
           <a:xfrm>
-            <a:off x="957406" y="4576469"/>
-            <a:ext cx="3176362" cy="646331"/>
+            <a:off x="5957422" y="4322494"/>
+            <a:ext cx="3468679" cy="584775"/>
           </a:xfrm>
           <a:prstGeom prst="rect">
             <a:avLst/>
@@ -10438,14 +10481,28 @@
           <a:lstStyle/>
           <a:p>
             <a:pPr>
-              <a:defRPr b="1" sz="1600">
+              <a:defRPr sz="1600" b="1">
                 <a:solidFill>
                   <a:srgbClr val="102C57"/>
                 </a:solidFill>
               </a:defRPr>
             </a:pPr>
             <a:r>
-              <a:t>AICTE STU ID: STU663c9352627131715245906</a:t>
+              <a:rPr dirty="0">
+                <a:latin typeface="Times New Roman" panose="02020603050405020304" pitchFamily="18" charset="0"/>
+                <a:cs typeface="Times New Roman" panose="02020603050405020304" pitchFamily="18" charset="0"/>
+              </a:rPr>
+              <a:t>AICTE STU ID: </a:t>
+            </a:r>
+            <a:r>
+              <a:rPr dirty="0">
+                <a:solidFill>
+                  <a:srgbClr val="FF0000"/>
+                </a:solidFill>
+                <a:latin typeface="Times New Roman" panose="02020603050405020304" pitchFamily="18" charset="0"/>
+                <a:cs typeface="Times New Roman" panose="02020603050405020304" pitchFamily="18" charset="0"/>
+              </a:rPr>
+              <a:t>STU663c9352627131715245906</a:t>
             </a:r>
           </a:p>
         </p:txBody>
@@ -11091,12 +11148,12 @@
         <p:spPr>
           <a:xfrm>
             <a:off x="675957" y="370589"/>
-            <a:ext cx="2981643" cy="830997"/>
+            <a:ext cx="6327958" cy="1010739"/>
           </a:xfrm>
         </p:spPr>
         <p:txBody>
           <a:bodyPr>
-            <a:normAutofit/>
+            <a:normAutofit fontScale="90000"/>
           </a:bodyPr>
           <a:lstStyle/>
           <a:p>
@@ -11108,7 +11165,21 @@
               </a:defRPr>
             </a:pPr>
             <a:r>
-              <a:t>RESULTS: Crop Economic Breakdown &amp; ANOVA Results</a:t>
+              <a:rPr sz="4400" dirty="0">
+                <a:solidFill>
+                  <a:srgbClr val="FF0000"/>
+                </a:solidFill>
+                <a:latin typeface="Times New Roman" panose="02020603050405020304" pitchFamily="18" charset="0"/>
+                <a:cs typeface="Times New Roman" panose="02020603050405020304" pitchFamily="18" charset="0"/>
+              </a:rPr>
+              <a:t>RESULTS: </a:t>
+            </a:r>
+            <a:br>
+              <a:rPr lang="en-US" dirty="0"/>
+            </a:br>
+            <a:r>
+              <a:rPr dirty="0"/>
+              <a:t>Crop Economic Breakdown &amp; ANOVA Results</a:t>
             </a:r>
           </a:p>
         </p:txBody>
@@ -11625,34 +11696,6 @@
           </a:p>
         </p:txBody>
       </p:sp>
-      <p:sp>
-        <p:nvSpPr>
-          <p:cNvPr id="10" name="Text Placeholder 1">
-            <a:extLst>
-              <a:ext uri="{FF2B5EF4-FFF2-40B4-BE49-F238E27FC236}">
-                <a16:creationId xmlns:a16="http://schemas.microsoft.com/office/drawing/2014/main" id="{F85C769B-425A-FE3B-E47A-3B747985DC52}"/>
-              </a:ext>
-            </a:extLst>
-          </p:cNvPr>
-          <p:cNvSpPr>
-            <a:spLocks noGrp="1"/>
-          </p:cNvSpPr>
-          <p:nvPr>
-            <p:ph type="body" sz="quarter" idx="12"/>
-          </p:nvPr>
-        </p:nvSpPr>
-        <p:spPr>
-          <a:xfrm>
-            <a:off x="807164" y="1431693"/>
-            <a:ext cx="4275138" cy="477520"/>
-          </a:xfrm>
-        </p:spPr>
-        <p:txBody>
-          <a:bodyPr/>
-          <a:lstStyle/>
-          <a:p/>
-        </p:txBody>
-      </p:sp>
       <p:pic>
         <p:nvPicPr>
           <p:cNvPr id="31" name="Picture 30" descr="crop_profit_comparison.png"/>
@@ -11685,8 +11728,8 @@
         </p:nvSpPr>
         <p:spPr>
           <a:xfrm>
-            <a:off x="6492240" y="1645920"/>
-            <a:ext cx="5303520" cy="3931920"/>
+            <a:off x="6317142" y="2103120"/>
+            <a:ext cx="3420245" cy="3549690"/>
           </a:xfrm>
           <a:prstGeom prst="rect">
             <a:avLst/>
@@ -11705,18 +11748,22 @@
               </a:spcAft>
             </a:pPr>
             <a:r>
-              <a:rPr b="1" sz="1300">
+              <a:rPr sz="1600" b="1" dirty="0">
                 <a:solidFill>
                   <a:srgbClr val="102C57"/>
                 </a:solidFill>
+                <a:latin typeface="Times New Roman" panose="02020603050405020304" pitchFamily="18" charset="0"/>
+                <a:cs typeface="Times New Roman" panose="02020603050405020304" pitchFamily="18" charset="0"/>
               </a:rPr>
               <a:t>• Economic Leaders: </a:t>
             </a:r>
             <a:r>
-              <a:rPr b="0" sz="1200">
+              <a:rPr sz="1600" b="0" dirty="0">
                 <a:solidFill>
                   <a:srgbClr val="282828"/>
                 </a:solidFill>
+                <a:latin typeface="Times New Roman" panose="02020603050405020304" pitchFamily="18" charset="0"/>
+                <a:cs typeface="Times New Roman" panose="02020603050405020304" pitchFamily="18" charset="0"/>
               </a:rPr>
               <a:t>Commercial cash crops (Sugarcane, Chilli, Cotton) achieved the highest net profits per hectare.</a:t>
             </a:r>
@@ -11728,18 +11775,22 @@
               </a:spcAft>
             </a:pPr>
             <a:r>
-              <a:rPr b="1" sz="1300">
+              <a:rPr sz="1600" b="1" dirty="0">
                 <a:solidFill>
                   <a:srgbClr val="102C57"/>
                 </a:solidFill>
+                <a:latin typeface="Times New Roman" panose="02020603050405020304" pitchFamily="18" charset="0"/>
+                <a:cs typeface="Times New Roman" panose="02020603050405020304" pitchFamily="18" charset="0"/>
               </a:rPr>
               <a:t>• Pulse &amp; Grain Value: </a:t>
             </a:r>
             <a:r>
-              <a:rPr b="0" sz="1200">
+              <a:rPr sz="1600" b="0" dirty="0">
                 <a:solidFill>
                   <a:srgbClr val="282828"/>
                 </a:solidFill>
+                <a:latin typeface="Times New Roman" panose="02020603050405020304" pitchFamily="18" charset="0"/>
+                <a:cs typeface="Times New Roman" panose="02020603050405020304" pitchFamily="18" charset="0"/>
               </a:rPr>
               <a:t>Pulses and Wheat provided critical soil nitrogen replenishment and steady seasonal cash flow.</a:t>
             </a:r>
@@ -11751,18 +11802,22 @@
               </a:spcAft>
             </a:pPr>
             <a:r>
-              <a:rPr b="1" sz="1300">
+              <a:rPr sz="1600" b="1" dirty="0">
                 <a:solidFill>
                   <a:srgbClr val="102C57"/>
                 </a:solidFill>
+                <a:latin typeface="Times New Roman" panose="02020603050405020304" pitchFamily="18" charset="0"/>
+                <a:cs typeface="Times New Roman" panose="02020603050405020304" pitchFamily="18" charset="0"/>
               </a:rPr>
               <a:t>• Hypothesis Testing: </a:t>
             </a:r>
             <a:r>
-              <a:rPr b="0" sz="1200">
+              <a:rPr sz="1600" b="0" dirty="0">
                 <a:solidFill>
                   <a:srgbClr val="282828"/>
                 </a:solidFill>
+                <a:latin typeface="Times New Roman" panose="02020603050405020304" pitchFamily="18" charset="0"/>
+                <a:cs typeface="Times New Roman" panose="02020603050405020304" pitchFamily="18" charset="0"/>
               </a:rPr>
               <a:t>One-Way ANOVA confirmed statistically significant differences (p &lt; 0.001) across seasons for Yield, Rainfall, and Net Profit.</a:t>
             </a:r>
@@ -12094,121 +12149,6 @@
                       </p:childTnLst>
                     </p:cTn>
                   </p:par>
-                  <p:par>
-                    <p:cTn id="24" fill="hold">
-                      <p:stCondLst>
-                        <p:cond delay="indefinite"/>
-                      </p:stCondLst>
-                      <p:childTnLst>
-                        <p:par>
-                          <p:cTn id="25" fill="hold">
-                            <p:stCondLst>
-                              <p:cond delay="0"/>
-                            </p:stCondLst>
-                            <p:childTnLst>
-                              <p:par>
-                                <p:cTn id="26" presetID="42" presetClass="entr" presetSubtype="0" fill="hold" grpId="0" nodeType="clickEffect">
-                                  <p:stCondLst>
-                                    <p:cond delay="0"/>
-                                  </p:stCondLst>
-                                  <p:childTnLst>
-                                    <p:set>
-                                      <p:cBhvr>
-                                        <p:cTn id="27" dur="1" fill="hold">
-                                          <p:stCondLst>
-                                            <p:cond delay="0"/>
-                                          </p:stCondLst>
-                                        </p:cTn>
-                                        <p:tgtEl>
-                                          <p:spTgt spid="10">
-                                            <p:txEl>
-                                              <p:pRg st="0" end="0"/>
-                                            </p:txEl>
-                                          </p:spTgt>
-                                        </p:tgtEl>
-                                        <p:attrNameLst>
-                                          <p:attrName>style.visibility</p:attrName>
-                                        </p:attrNameLst>
-                                      </p:cBhvr>
-                                      <p:to>
-                                        <p:strVal val="visible"/>
-                                      </p:to>
-                                    </p:set>
-                                    <p:animEffect transition="in" filter="fade">
-                                      <p:cBhvr>
-                                        <p:cTn id="28" dur="1000"/>
-                                        <p:tgtEl>
-                                          <p:spTgt spid="10">
-                                            <p:txEl>
-                                              <p:pRg st="0" end="0"/>
-                                            </p:txEl>
-                                          </p:spTgt>
-                                        </p:tgtEl>
-                                      </p:cBhvr>
-                                    </p:animEffect>
-                                    <p:anim calcmode="lin" valueType="num">
-                                      <p:cBhvr>
-                                        <p:cTn id="29" dur="1000" fill="hold"/>
-                                        <p:tgtEl>
-                                          <p:spTgt spid="10">
-                                            <p:txEl>
-                                              <p:pRg st="0" end="0"/>
-                                            </p:txEl>
-                                          </p:spTgt>
-                                        </p:tgtEl>
-                                        <p:attrNameLst>
-                                          <p:attrName>ppt_x</p:attrName>
-                                        </p:attrNameLst>
-                                      </p:cBhvr>
-                                      <p:tavLst>
-                                        <p:tav tm="0">
-                                          <p:val>
-                                            <p:strVal val="#ppt_x"/>
-                                          </p:val>
-                                        </p:tav>
-                                        <p:tav tm="100000">
-                                          <p:val>
-                                            <p:strVal val="#ppt_x"/>
-                                          </p:val>
-                                        </p:tav>
-                                      </p:tavLst>
-                                    </p:anim>
-                                    <p:anim calcmode="lin" valueType="num">
-                                      <p:cBhvr>
-                                        <p:cTn id="30" dur="1000" fill="hold"/>
-                                        <p:tgtEl>
-                                          <p:spTgt spid="10">
-                                            <p:txEl>
-                                              <p:pRg st="0" end="0"/>
-                                            </p:txEl>
-                                          </p:spTgt>
-                                        </p:tgtEl>
-                                        <p:attrNameLst>
-                                          <p:attrName>ppt_y</p:attrName>
-                                        </p:attrNameLst>
-                                      </p:cBhvr>
-                                      <p:tavLst>
-                                        <p:tav tm="0">
-                                          <p:val>
-                                            <p:strVal val="#ppt_y+.1"/>
-                                          </p:val>
-                                        </p:tav>
-                                        <p:tav tm="100000">
-                                          <p:val>
-                                            <p:strVal val="#ppt_y"/>
-                                          </p:val>
-                                        </p:tav>
-                                      </p:tavLst>
-                                    </p:anim>
-                                  </p:childTnLst>
-                                </p:cTn>
-                              </p:par>
-                            </p:childTnLst>
-                          </p:cTn>
-                        </p:par>
-                      </p:childTnLst>
-                    </p:cTn>
-                  </p:par>
                 </p:childTnLst>
               </p:cTn>
               <p:prevCondLst>
@@ -12234,7 +12174,6 @@
       <p:bldP spid="4" grpId="0"/>
       <p:bldP spid="7" grpId="0"/>
       <p:bldP spid="8" grpId="0"/>
-      <p:bldP spid="10" grpId="0" build="p"/>
     </p:bldLst>
   </p:timing>
 </p:sld>
@@ -12321,8 +12260,14 @@
           <a:lstStyle/>
           <a:p>
             <a:r>
-              <a:rPr lang="en-IN" sz="4000" dirty="0"/>
-              <a:t>Future scope</a:t>
+              <a:rPr lang="en-IN" sz="4400" dirty="0">
+                <a:solidFill>
+                  <a:srgbClr val="FF0000"/>
+                </a:solidFill>
+                <a:latin typeface="Times New Roman" panose="02020603050405020304" pitchFamily="18" charset="0"/>
+                <a:cs typeface="Times New Roman" panose="02020603050405020304" pitchFamily="18" charset="0"/>
+              </a:rPr>
+              <a:t>FUTURE SCOPE</a:t>
             </a:r>
           </a:p>
         </p:txBody>
@@ -12847,8 +12792,8 @@
         </p:nvSpPr>
         <p:spPr>
           <a:xfrm>
-            <a:off x="731520" y="1645920"/>
-            <a:ext cx="10515600" cy="4114800"/>
+            <a:off x="675957" y="2146460"/>
+            <a:ext cx="8490301" cy="3585597"/>
           </a:xfrm>
           <a:prstGeom prst="rect">
             <a:avLst/>
@@ -12867,18 +12812,22 @@
               </a:spcAft>
             </a:pPr>
             <a:r>
-              <a:rPr b="1" sz="1400">
+              <a:rPr sz="1600" b="1" dirty="0">
                 <a:solidFill>
                   <a:srgbClr val="102C57"/>
                 </a:solidFill>
+                <a:latin typeface="Times New Roman" panose="02020603050405020304" pitchFamily="18" charset="0"/>
+                <a:cs typeface="Times New Roman" panose="02020603050405020304" pitchFamily="18" charset="0"/>
               </a:rPr>
               <a:t>1. Real-Time IoT &amp; Smart Sensor Integration: </a:t>
             </a:r>
             <a:r>
-              <a:rPr b="0" sz="1300">
+              <a:rPr sz="1600" b="0" dirty="0">
                 <a:solidFill>
                   <a:srgbClr val="282828"/>
                 </a:solidFill>
+                <a:latin typeface="Times New Roman" panose="02020603050405020304" pitchFamily="18" charset="0"/>
+                <a:cs typeface="Times New Roman" panose="02020603050405020304" pitchFamily="18" charset="0"/>
               </a:rPr>
               <a:t>Integrate on-farm IoT sensors for continuous telemetry streaming of real-time soil moisture, temperature, and electrical conductivity to automate drip irrigation valves.</a:t>
             </a:r>
@@ -12890,18 +12839,22 @@
               </a:spcAft>
             </a:pPr>
             <a:r>
-              <a:rPr b="1" sz="1400">
+              <a:rPr sz="1600" b="1" dirty="0">
                 <a:solidFill>
                   <a:srgbClr val="102C57"/>
                 </a:solidFill>
+                <a:latin typeface="Times New Roman" panose="02020603050405020304" pitchFamily="18" charset="0"/>
+                <a:cs typeface="Times New Roman" panose="02020603050405020304" pitchFamily="18" charset="0"/>
               </a:rPr>
               <a:t>2. Satellite Remote Sensing &amp; Computer Vision: </a:t>
             </a:r>
             <a:r>
-              <a:rPr b="0" sz="1300">
+              <a:rPr sz="1600" b="0" dirty="0">
                 <a:solidFill>
                   <a:srgbClr val="282828"/>
                 </a:solidFill>
+                <a:latin typeface="Times New Roman" panose="02020603050405020304" pitchFamily="18" charset="0"/>
+                <a:cs typeface="Times New Roman" panose="02020603050405020304" pitchFamily="18" charset="0"/>
               </a:rPr>
               <a:t>Leverage high-resolution Sentinel/Landsat multispectral imagery (NDVI, NDWI) and drone surveys to spot localized crop stress, nutrient deficiencies, and pest infestations.</a:t>
             </a:r>
@@ -12913,18 +12866,22 @@
               </a:spcAft>
             </a:pPr>
             <a:r>
-              <a:rPr b="1" sz="1400">
+              <a:rPr sz="1600" b="1" dirty="0">
                 <a:solidFill>
                   <a:srgbClr val="102C57"/>
                 </a:solidFill>
+                <a:latin typeface="Times New Roman" panose="02020603050405020304" pitchFamily="18" charset="0"/>
+                <a:cs typeface="Times New Roman" panose="02020603050405020304" pitchFamily="18" charset="0"/>
               </a:rPr>
               <a:t>3. Deep Learning &amp; Transformer-based Weather Forecasting: </a:t>
             </a:r>
             <a:r>
-              <a:rPr b="0" sz="1300">
+              <a:rPr sz="1600" b="0" dirty="0">
                 <a:solidFill>
                   <a:srgbClr val="282828"/>
                 </a:solidFill>
+                <a:latin typeface="Times New Roman" panose="02020603050405020304" pitchFamily="18" charset="0"/>
+                <a:cs typeface="Times New Roman" panose="02020603050405020304" pitchFamily="18" charset="0"/>
               </a:rPr>
               <a:t>Incorporate regional numerical weather prediction and transformer models to predict monsoon onset anomalies, unseasonal rains, and heatwaves.</a:t>
             </a:r>
@@ -12936,20 +12893,44 @@
               </a:spcAft>
             </a:pPr>
             <a:r>
-              <a:rPr b="1" sz="1400">
+              <a:rPr sz="1600" b="1" dirty="0">
                 <a:solidFill>
                   <a:srgbClr val="102C57"/>
                 </a:solidFill>
+                <a:latin typeface="Times New Roman" panose="02020603050405020304" pitchFamily="18" charset="0"/>
+                <a:cs typeface="Times New Roman" panose="02020603050405020304" pitchFamily="18" charset="0"/>
               </a:rPr>
               <a:t>4. Mobile Decision Support Platform: </a:t>
             </a:r>
             <a:r>
-              <a:rPr b="0" sz="1300">
+              <a:rPr sz="1600" b="0" dirty="0">
                 <a:solidFill>
                   <a:srgbClr val="282828"/>
                 </a:solidFill>
+                <a:latin typeface="Times New Roman" panose="02020603050405020304" pitchFamily="18" charset="0"/>
+                <a:cs typeface="Times New Roman" panose="02020603050405020304" pitchFamily="18" charset="0"/>
               </a:rPr>
-              <a:t>Deploy lightweight quantized XGBoost models into a multilingual mobile app offering personalized, voice-assisted advisories for rural farmers without continuous internet access.</a:t>
+              <a:t>Deploy lightweight quantized </a:t>
+            </a:r>
+            <a:r>
+              <a:rPr sz="1600" b="0" dirty="0" err="1">
+                <a:solidFill>
+                  <a:srgbClr val="282828"/>
+                </a:solidFill>
+                <a:latin typeface="Times New Roman" panose="02020603050405020304" pitchFamily="18" charset="0"/>
+                <a:cs typeface="Times New Roman" panose="02020603050405020304" pitchFamily="18" charset="0"/>
+              </a:rPr>
+              <a:t>XGBoost</a:t>
+            </a:r>
+            <a:r>
+              <a:rPr sz="1600" b="0" dirty="0">
+                <a:solidFill>
+                  <a:srgbClr val="282828"/>
+                </a:solidFill>
+                <a:latin typeface="Times New Roman" panose="02020603050405020304" pitchFamily="18" charset="0"/>
+                <a:cs typeface="Times New Roman" panose="02020603050405020304" pitchFamily="18" charset="0"/>
+              </a:rPr>
+              <a:t> models into a multilingual mobile app offering personalized, voice-assisted advisories for rural farmers without continuous internet access.</a:t>
             </a:r>
           </a:p>
         </p:txBody>
@@ -13390,8 +13371,14 @@
           <a:lstStyle/>
           <a:p>
             <a:r>
-              <a:rPr lang="en-IN" sz="4000" dirty="0"/>
-              <a:t>GitHub Link</a:t>
+              <a:rPr lang="en-IN" sz="4000" dirty="0">
+                <a:solidFill>
+                  <a:srgbClr val="FF0000"/>
+                </a:solidFill>
+                <a:latin typeface="Times New Roman" panose="02020603050405020304" pitchFamily="18" charset="0"/>
+                <a:cs typeface="Times New Roman" panose="02020603050405020304" pitchFamily="18" charset="0"/>
+              </a:rPr>
+              <a:t>GITHUB LINK</a:t>
             </a:r>
           </a:p>
         </p:txBody>
@@ -13922,8 +13909,8 @@
         </p:nvSpPr>
         <p:spPr>
           <a:xfrm>
-            <a:off x="729256" y="1440320"/>
-            <a:ext cx="7232875" cy="646331"/>
+            <a:off x="675957" y="1275371"/>
+            <a:ext cx="8881672" cy="369332"/>
           </a:xfrm>
           <a:prstGeom prst="rect">
             <a:avLst/>
@@ -13944,8 +13931,10 @@
               </a:defRPr>
             </a:pPr>
             <a:r>
-              <a:t>https://github.com/ksmashhero06/-Seasonal-Agriculture-Performance-Analysis-.git</a:t>
+              <a:rPr lang="en-US" dirty="0"/>
+              <a:t>https://github.com/Ksmashhero06/Seasonal-Agriculture-Performance-Analysis/</a:t>
             </a:r>
+            <a:endParaRPr dirty="0"/>
           </a:p>
         </p:txBody>
       </p:sp>
@@ -14374,8 +14363,8 @@
         </p:nvSpPr>
         <p:spPr>
           <a:xfrm>
-            <a:off x="675957" y="370589"/>
-            <a:ext cx="8351388" cy="884658"/>
+            <a:off x="535022" y="370589"/>
+            <a:ext cx="9572016" cy="884658"/>
           </a:xfrm>
         </p:spPr>
         <p:txBody>
@@ -14385,15 +14374,21 @@
           <a:lstStyle/>
           <a:p>
             <a:r>
-              <a:rPr lang="en-IN" sz="3200" dirty="0"/>
-              <a:t>VOIS Course completion certificate - </a:t>
+              <a:rPr lang="en-IN" sz="3600" dirty="0">
+                <a:solidFill>
+                  <a:srgbClr val="FF0000"/>
+                </a:solidFill>
+                <a:latin typeface="Times New Roman" panose="02020603050405020304" pitchFamily="18" charset="0"/>
+                <a:cs typeface="Times New Roman" panose="02020603050405020304" pitchFamily="18" charset="0"/>
+              </a:rPr>
+              <a:t>VOIS COURSE COMPLETION CERTIFICATE </a:t>
             </a:r>
             <a:br>
               <a:rPr lang="en-IN" sz="3200" dirty="0"/>
             </a:br>
             <a:r>
               <a:rPr lang="en-IN" sz="3200" dirty="0"/>
-              <a:t>Course name- Data Visualization </a:t>
+              <a:t>Course name: Data Visualization </a:t>
             </a:r>
           </a:p>
         </p:txBody>
@@ -14910,6 +14905,37 @@
           </a:p>
         </p:txBody>
       </p:sp>
+      <p:pic>
+        <p:nvPicPr>
+          <p:cNvPr id="3" name="Picture 2">
+            <a:extLst>
+              <a:ext uri="{FF2B5EF4-FFF2-40B4-BE49-F238E27FC236}">
+                <a16:creationId xmlns:a16="http://schemas.microsoft.com/office/drawing/2014/main" id="{65530D36-E44D-B79F-3F14-E427FC00099A}"/>
+              </a:ext>
+            </a:extLst>
+          </p:cNvPr>
+          <p:cNvPicPr>
+            <a:picLocks noChangeAspect="1"/>
+          </p:cNvPicPr>
+          <p:nvPr/>
+        </p:nvPicPr>
+        <p:blipFill>
+          <a:blip r:embed="rId3"/>
+          <a:srcRect l="919" t="1724"/>
+          <a:stretch>
+            <a:fillRect/>
+          </a:stretch>
+        </p:blipFill>
+        <p:spPr>
+          <a:xfrm>
+            <a:off x="675957" y="1608410"/>
+            <a:ext cx="7851503" cy="4332489"/>
+          </a:xfrm>
+          <a:prstGeom prst="rect">
+            <a:avLst/>
+          </a:prstGeom>
+        </p:spPr>
+      </p:pic>
     </p:spTree>
     <p:extLst>
       <p:ext uri="{BB962C8B-B14F-4D97-AF65-F5344CB8AC3E}">
@@ -15299,24 +15325,30 @@
           </p:nvPr>
         </p:nvSpPr>
         <p:spPr>
+          <a:xfrm>
+            <a:off x="1429966" y="2545370"/>
+            <a:ext cx="6935822" cy="700114"/>
+          </a:xfrm>
           <a:prstGeom prst="rect">
             <a:avLst/>
           </a:prstGeom>
         </p:spPr>
         <p:txBody>
           <a:bodyPr anchor="ctr">
-            <a:normAutofit fontScale="90000"/>
+            <a:noAutofit/>
           </a:bodyPr>
           <a:lstStyle/>
           <a:p>
             <a:pPr algn="ctr"/>
             <a:r>
-              <a:rPr lang="en-US" sz="4800" b="1" dirty="0">
-                <a:solidFill>
-                  <a:schemeClr val="tx1"/>
-                </a:solidFill>
+              <a:rPr lang="en-US" sz="5400" b="1" dirty="0">
+                <a:solidFill>
+                  <a:srgbClr val="FF0000"/>
+                </a:solidFill>
+                <a:latin typeface="Times New Roman" panose="02020603050405020304" pitchFamily="18" charset="0"/>
+                <a:cs typeface="Times New Roman" panose="02020603050405020304" pitchFamily="18" charset="0"/>
               </a:rPr>
-              <a:t>Thank you</a:t>
+              <a:t>THANK YOU</a:t>
             </a:r>
           </a:p>
         </p:txBody>
@@ -16668,38 +16700,6 @@
           </a:prstGeom>
         </p:spPr>
       </p:pic>
-      <p:sp>
-        <p:nvSpPr>
-          <p:cNvPr id="12" name="Text Placeholder 11">
-            <a:extLst>
-              <a:ext uri="{FF2B5EF4-FFF2-40B4-BE49-F238E27FC236}">
-                <a16:creationId xmlns:a16="http://schemas.microsoft.com/office/drawing/2014/main" id="{BC277FD7-925B-4C3D-A364-118403201507}"/>
-              </a:ext>
-            </a:extLst>
-          </p:cNvPr>
-          <p:cNvSpPr>
-            <a:spLocks noGrp="1"/>
-          </p:cNvSpPr>
-          <p:nvPr>
-            <p:ph type="body" sz="quarter" idx="12"/>
-          </p:nvPr>
-        </p:nvSpPr>
-        <p:spPr>
-          <a:xfrm>
-            <a:off x="2975013" y="3962573"/>
-            <a:ext cx="2139696" cy="344312"/>
-          </a:xfrm>
-        </p:spPr>
-        <p:txBody>
-          <a:bodyPr>
-            <a:normAutofit fontScale="92500" lnSpcReduction="20000"/>
-          </a:bodyPr>
-          <a:lstStyle/>
-          <a:p>
-            <a:endParaRPr lang="en-IN" dirty="0"/>
-          </a:p>
-        </p:txBody>
-      </p:sp>
     </p:spTree>
     <p:extLst>
       <p:ext uri="{BB962C8B-B14F-4D97-AF65-F5344CB8AC3E}">
@@ -17374,30 +17374,33 @@
         </p:nvSpPr>
         <p:spPr>
           <a:xfrm>
-            <a:off x="1046480" y="1875556"/>
-            <a:ext cx="6431280" cy="3607987"/>
+            <a:off x="260830" y="1978168"/>
+            <a:ext cx="7734854" cy="4329415"/>
           </a:xfrm>
         </p:spPr>
         <p:txBody>
           <a:bodyPr vert="horz" lIns="91440" tIns="45720" rIns="91440" bIns="45720" rtlCol="0" anchor="t">
-            <a:normAutofit fontScale="70000" lnSpcReduction="20000"/>
+            <a:noAutofit/>
           </a:bodyPr>
           <a:lstStyle/>
           <a:p>
-            <a:pPr>
+            <a:pPr marL="0" indent="0" algn="just">
               <a:lnSpc>
                 <a:spcPct val="100000"/>
               </a:lnSpc>
+              <a:buNone/>
             </a:pPr>
             <a:r>
-              <a:rPr lang="en-IN" sz="2800" dirty="0"/>
-              <a:t>(</a:t>
-            </a:r>
-            <a:r>
-              <a:rPr lang="en-US" sz="2800" dirty="0"/>
+              <a:rPr lang="en-US" sz="2400" dirty="0">
+                <a:latin typeface="Times New Roman" panose="02020603050405020304" pitchFamily="18" charset="0"/>
+                <a:cs typeface="Times New Roman" panose="02020603050405020304" pitchFamily="18" charset="0"/>
+              </a:rPr>
               <a:t>Agricultural activities are influenced by seasonal variations in environmental conditions, farming practices, resource availability and market conditions. As a result, agricultural performance may differ from one season to another. However, raw agricultural data does not clearly explain how agricultural performance changes across seasons or what patterns can be observed in different seasonal conditions. The problem is to analyze the given agricultural dataset and investigate seasonal differences in agricultural performance by identifying meaningful patterns, trends, relationships and variations within the available data.</a:t>
             </a:r>
-            <a:endParaRPr lang="en-IN" sz="2800" dirty="0"/>
+            <a:endParaRPr lang="en-IN" sz="2400" dirty="0">
+              <a:latin typeface="Times New Roman" panose="02020603050405020304" pitchFamily="18" charset="0"/>
+              <a:cs typeface="Times New Roman" panose="02020603050405020304" pitchFamily="18" charset="0"/>
+            </a:endParaRPr>
           </a:p>
         </p:txBody>
       </p:sp>
@@ -17430,10 +17433,22 @@
           <a:lstStyle/>
           <a:p>
             <a:r>
-              <a:rPr lang="en-US" dirty="0"/>
+              <a:rPr lang="en-US" dirty="0">
+                <a:solidFill>
+                  <a:srgbClr val="FF0000"/>
+                </a:solidFill>
+                <a:latin typeface="Times New Roman" panose="02020603050405020304" pitchFamily="18" charset="0"/>
+                <a:cs typeface="Times New Roman" panose="02020603050405020304" pitchFamily="18" charset="0"/>
+              </a:rPr>
               <a:t>PROBLEM  STATEMENT</a:t>
             </a:r>
-            <a:endParaRPr lang="en-IN" dirty="0"/>
+            <a:endParaRPr lang="en-IN" dirty="0">
+              <a:solidFill>
+                <a:srgbClr val="FF0000"/>
+              </a:solidFill>
+              <a:latin typeface="Times New Roman" panose="02020603050405020304" pitchFamily="18" charset="0"/>
+              <a:cs typeface="Times New Roman" panose="02020603050405020304" pitchFamily="18" charset="0"/>
+            </a:endParaRPr>
           </a:p>
         </p:txBody>
       </p:sp>
@@ -17803,7 +17818,7 @@
         <p:spPr>
           <a:xfrm>
             <a:off x="660399" y="805213"/>
-            <a:ext cx="6276109" cy="830997"/>
+            <a:ext cx="7296827" cy="830997"/>
           </a:xfrm>
         </p:spPr>
         <p:txBody>
@@ -17813,16 +17828,18 @@
           <a:lstStyle/>
           <a:p>
             <a:r>
-              <a:rPr lang="en-GB" dirty="0"/>
-              <a:t>Project Description</a:t>
+              <a:rPr lang="en-GB" dirty="0">
+                <a:solidFill>
+                  <a:srgbClr val="FF0000"/>
+                </a:solidFill>
+                <a:latin typeface="Times New Roman" panose="02020603050405020304" pitchFamily="18" charset="0"/>
+                <a:cs typeface="Times New Roman" panose="02020603050405020304" pitchFamily="18" charset="0"/>
+              </a:rPr>
+              <a:t>PROJECT DESCRIPTION</a:t>
             </a:r>
             <a:br>
               <a:rPr lang="en-GB" dirty="0"/>
             </a:br>
-            <a:r>
-              <a:rPr lang="en-GB" dirty="0"/>
-              <a:t>[write detail description about your project ] </a:t>
-            </a:r>
             <a:br>
               <a:rPr lang="en-GB" dirty="0"/>
             </a:br>
@@ -17897,8 +17914,8 @@
         </p:nvSpPr>
         <p:spPr>
           <a:xfrm>
-            <a:off x="731520" y="1645920"/>
-            <a:ext cx="10515600" cy="4114800"/>
+            <a:off x="264591" y="2009256"/>
+            <a:ext cx="9210149" cy="4401205"/>
           </a:xfrm>
           <a:prstGeom prst="rect">
             <a:avLst/>
@@ -17911,116 +17928,186 @@
           </a:bodyPr>
           <a:lstStyle/>
           <a:p>
-            <a:pPr>
+            <a:pPr marL="285750" indent="-285750">
               <a:spcAft>
                 <a:spcPts val="1200"/>
               </a:spcAft>
+              <a:buFont typeface="Wingdings" panose="05000000000000000000" pitchFamily="2" charset="2"/>
+              <a:buChar char="Ø"/>
             </a:pPr>
             <a:r>
-              <a:rPr b="1" sz="1400">
+              <a:rPr sz="1600" b="1" dirty="0">
                 <a:solidFill>
                   <a:srgbClr val="102C57"/>
                 </a:solidFill>
+                <a:latin typeface="Times New Roman" panose="02020603050405020304" pitchFamily="18" charset="0"/>
+                <a:cs typeface="Times New Roman" panose="02020603050405020304" pitchFamily="18" charset="0"/>
               </a:rPr>
-              <a:t>• Overview: </a:t>
+              <a:t>Overview: </a:t>
             </a:r>
             <a:r>
-              <a:rPr b="0" sz="1300">
+              <a:rPr sz="1600" b="0" dirty="0">
                 <a:solidFill>
                   <a:srgbClr val="282828"/>
                 </a:solidFill>
+                <a:latin typeface="Times New Roman" panose="02020603050405020304" pitchFamily="18" charset="0"/>
+                <a:cs typeface="Times New Roman" panose="02020603050405020304" pitchFamily="18" charset="0"/>
               </a:rPr>
               <a:t>Comprehensive data science and machine learning project analyzing 4,000 agricultural farm operations across 8 major Indian states, 8 crops, and 3 distinct agricultural seasons (Kharif, Rabi, and Zaid).</a:t>
             </a:r>
           </a:p>
           <a:p>
-            <a:pPr>
+            <a:pPr marL="285750" indent="-285750">
               <a:spcAft>
                 <a:spcPts val="1200"/>
               </a:spcAft>
+              <a:buFont typeface="Wingdings" panose="05000000000000000000" pitchFamily="2" charset="2"/>
+              <a:buChar char="Ø"/>
             </a:pPr>
             <a:r>
-              <a:rPr b="1" sz="1400">
+              <a:rPr sz="1600" b="1" dirty="0">
                 <a:solidFill>
                   <a:srgbClr val="102C57"/>
                 </a:solidFill>
+                <a:latin typeface="Times New Roman" panose="02020603050405020304" pitchFamily="18" charset="0"/>
+                <a:cs typeface="Times New Roman" panose="02020603050405020304" pitchFamily="18" charset="0"/>
               </a:rPr>
-              <a:t>• Key Investigations: </a:t>
+              <a:t>Key Investigations: </a:t>
             </a:r>
             <a:r>
-              <a:rPr b="0" sz="1300">
+              <a:rPr sz="1600" b="0" dirty="0">
                 <a:solidFill>
                   <a:srgbClr val="282828"/>
                 </a:solidFill>
+                <a:latin typeface="Times New Roman" panose="02020603050405020304" pitchFamily="18" charset="0"/>
+                <a:cs typeface="Times New Roman" panose="02020603050405020304" pitchFamily="18" charset="0"/>
               </a:rPr>
-              <a:t>Explores the intricate relationships between seasonal weather patterns (rainfall, temperature, humidity, sunlight), soil nutrient profiles (N-P-K, pH, moisture), agronomic inputs (irrigation technologies, fertilizers, pesticides), and economic outcomes (production, costs, revenue, net profit, and water efficiency).</a:t>
+              <a:t>Explore</a:t>
             </a:r>
-          </a:p>
-          <a:p>
-            <a:pPr>
+            <a:r>
+              <a:rPr lang="en-US" sz="1600" b="0" dirty="0">
+                <a:solidFill>
+                  <a:srgbClr val="282828"/>
+                </a:solidFill>
+                <a:latin typeface="Times New Roman" panose="02020603050405020304" pitchFamily="18" charset="0"/>
+                <a:cs typeface="Times New Roman" panose="02020603050405020304" pitchFamily="18" charset="0"/>
+              </a:rPr>
+              <a:t>d</a:t>
+            </a:r>
+            <a:r>
+              <a:rPr sz="1600" b="0" dirty="0">
+                <a:solidFill>
+                  <a:srgbClr val="282828"/>
+                </a:solidFill>
+                <a:latin typeface="Times New Roman" panose="02020603050405020304" pitchFamily="18" charset="0"/>
+                <a:cs typeface="Times New Roman" panose="02020603050405020304" pitchFamily="18" charset="0"/>
+              </a:rPr>
+              <a:t> the intricate relationships between seasonal weather patterns (rainfall, temperature, humidity, sunlight), soil nutrient profiles (N-P-K, pH, moisture), agronomic inputs (irrigation technologies, fertilizers, pesticides), and economic outcomes (production, costs, revenue, net profit, and water efficiency).</a:t>
+            </a:r>
+          </a:p>
+          <a:p>
+            <a:pPr marL="285750" indent="-285750">
               <a:spcAft>
                 <a:spcPts val="1200"/>
               </a:spcAft>
+              <a:buFont typeface="Wingdings" panose="05000000000000000000" pitchFamily="2" charset="2"/>
+              <a:buChar char="Ø"/>
             </a:pPr>
             <a:r>
-              <a:rPr b="1" sz="1400">
+              <a:rPr sz="1600" b="1" dirty="0">
                 <a:solidFill>
                   <a:srgbClr val="102C57"/>
                 </a:solidFill>
+                <a:latin typeface="Times New Roman" panose="02020603050405020304" pitchFamily="18" charset="0"/>
+                <a:cs typeface="Times New Roman" panose="02020603050405020304" pitchFamily="18" charset="0"/>
               </a:rPr>
-              <a:t>• Methodology &amp; Rigor: </a:t>
+              <a:t>Methodology &amp; Rigor: </a:t>
             </a:r>
             <a:r>
-              <a:rPr b="0" sz="1300">
+              <a:rPr sz="1600" b="0" dirty="0">
                 <a:solidFill>
                   <a:srgbClr val="282828"/>
                 </a:solidFill>
+                <a:latin typeface="Times New Roman" panose="02020603050405020304" pitchFamily="18" charset="0"/>
+                <a:cs typeface="Times New Roman" panose="02020603050405020304" pitchFamily="18" charset="0"/>
               </a:rPr>
               <a:t>Implements domain-aware data imputation, multi-season exploratory data analysis (EDA), statistical hypothesis testing (One-way ANOVA), and machine learning regression and classification models.</a:t>
             </a:r>
           </a:p>
           <a:p>
-            <a:pPr>
+            <a:pPr marL="285750" indent="-285750">
               <a:spcAft>
                 <a:spcPts val="1200"/>
               </a:spcAft>
+              <a:buFont typeface="Wingdings" panose="05000000000000000000" pitchFamily="2" charset="2"/>
+              <a:buChar char="Ø"/>
             </a:pPr>
             <a:r>
-              <a:rPr b="1" sz="1400">
+              <a:rPr sz="1600" b="1" dirty="0">
                 <a:solidFill>
                   <a:srgbClr val="102C57"/>
                 </a:solidFill>
+                <a:latin typeface="Times New Roman" panose="02020603050405020304" pitchFamily="18" charset="0"/>
+                <a:cs typeface="Times New Roman" panose="02020603050405020304" pitchFamily="18" charset="0"/>
               </a:rPr>
-              <a:t>• Predictive Modeling: </a:t>
+              <a:t>Predictive Modeling: </a:t>
             </a:r>
             <a:r>
-              <a:rPr b="0" sz="1300">
+              <a:rPr sz="1600" b="0" dirty="0">
                 <a:solidFill>
                   <a:srgbClr val="282828"/>
                 </a:solidFill>
+                <a:latin typeface="Times New Roman" panose="02020603050405020304" pitchFamily="18" charset="0"/>
+                <a:cs typeface="Times New Roman" panose="02020603050405020304" pitchFamily="18" charset="0"/>
               </a:rPr>
-              <a:t>Trains and benchmarks multiple algorithms (Linear/Ridge Regression, Random Forest, Gradient Boosting, XGBoost), achieving an outstanding R² score of 0.990 for Crop Yield Prediction and 92.25% accuracy for Farm Profitability Classification.</a:t>
+              <a:t>Trains and benchmarks multiple algorithms (Linear/Ridge Regression, Random Forest, Gradient Boosting, </a:t>
             </a:r>
-          </a:p>
-          <a:p>
-            <a:pPr>
+            <a:r>
+              <a:rPr sz="1600" b="0" dirty="0" err="1">
+                <a:solidFill>
+                  <a:srgbClr val="282828"/>
+                </a:solidFill>
+                <a:latin typeface="Times New Roman" panose="02020603050405020304" pitchFamily="18" charset="0"/>
+                <a:cs typeface="Times New Roman" panose="02020603050405020304" pitchFamily="18" charset="0"/>
+              </a:rPr>
+              <a:t>XGBoost</a:t>
+            </a:r>
+            <a:r>
+              <a:rPr sz="1600" b="0" dirty="0">
+                <a:solidFill>
+                  <a:srgbClr val="282828"/>
+                </a:solidFill>
+                <a:latin typeface="Times New Roman" panose="02020603050405020304" pitchFamily="18" charset="0"/>
+                <a:cs typeface="Times New Roman" panose="02020603050405020304" pitchFamily="18" charset="0"/>
+              </a:rPr>
+              <a:t>), achieving an outstanding R² score of 0.990 for Crop Yield Prediction and 92.25% accuracy for Farm Profitability Classification.</a:t>
+            </a:r>
+          </a:p>
+          <a:p>
+            <a:pPr marL="285750" indent="-285750">
               <a:spcAft>
                 <a:spcPts val="1200"/>
               </a:spcAft>
+              <a:buFont typeface="Wingdings" panose="05000000000000000000" pitchFamily="2" charset="2"/>
+              <a:buChar char="Ø"/>
             </a:pPr>
             <a:r>
-              <a:rPr b="1" sz="1400">
+              <a:rPr sz="1600" b="1" dirty="0">
                 <a:solidFill>
                   <a:srgbClr val="102C57"/>
                 </a:solidFill>
+                <a:latin typeface="Times New Roman" panose="02020603050405020304" pitchFamily="18" charset="0"/>
+                <a:cs typeface="Times New Roman" panose="02020603050405020304" pitchFamily="18" charset="0"/>
               </a:rPr>
-              <a:t>• Strategic Value: </a:t>
+              <a:t>Strategic Value: </a:t>
             </a:r>
             <a:r>
-              <a:rPr b="0" sz="1300">
+              <a:rPr sz="1600" b="0" dirty="0">
                 <a:solidFill>
                   <a:srgbClr val="282828"/>
                 </a:solidFill>
+                <a:latin typeface="Times New Roman" panose="02020603050405020304" pitchFamily="18" charset="0"/>
+                <a:cs typeface="Times New Roman" panose="02020603050405020304" pitchFamily="18" charset="0"/>
               </a:rPr>
               <a:t>Delivers actionable, data-driven seasonal crop planning and irrigation recommendations to optimize resource efficiency and farmer livelihoods.</a:t>
             </a:r>
@@ -18191,43 +18278,6 @@
       </p:grpSpPr>
       <p:sp>
         <p:nvSpPr>
-          <p:cNvPr id="2" name="Text Placeholder 1">
-            <a:extLst>
-              <a:ext uri="{FF2B5EF4-FFF2-40B4-BE49-F238E27FC236}">
-                <a16:creationId xmlns:a16="http://schemas.microsoft.com/office/drawing/2014/main" id="{664E3B60-2780-459A-8583-F095D5E7463A}"/>
-              </a:ext>
-            </a:extLst>
-          </p:cNvPr>
-          <p:cNvSpPr>
-            <a:spLocks noGrp="1"/>
-          </p:cNvSpPr>
-          <p:nvPr>
-            <p:ph type="body" sz="quarter" idx="12"/>
-          </p:nvPr>
-        </p:nvSpPr>
-        <p:spPr>
-          <a:xfrm>
-            <a:off x="721359" y="1991360"/>
-            <a:ext cx="7904481" cy="3990023"/>
-          </a:xfrm>
-        </p:spPr>
-        <p:txBody>
-          <a:bodyPr>
-            <a:normAutofit/>
-          </a:bodyPr>
-          <a:lstStyle/>
-          <a:p>
-            <a:pPr algn="just">
-              <a:lnSpc>
-                <a:spcPct val="150000"/>
-              </a:lnSpc>
-            </a:pPr>
-            <a:endParaRPr lang="en-IN" sz="3600" dirty="0"/>
-          </a:p>
-        </p:txBody>
-      </p:sp>
-      <p:sp>
-        <p:nvSpPr>
           <p:cNvPr id="4" name="Title 3">
             <a:extLst>
               <a:ext uri="{FF2B5EF4-FFF2-40B4-BE49-F238E27FC236}">
@@ -18255,10 +18305,22 @@
           <a:lstStyle/>
           <a:p>
             <a:r>
-              <a:rPr lang="en-US" sz="3200" dirty="0"/>
+              <a:rPr lang="en-US" sz="4400" dirty="0">
+                <a:solidFill>
+                  <a:srgbClr val="FF0000"/>
+                </a:solidFill>
+                <a:latin typeface="Times New Roman" panose="02020603050405020304" pitchFamily="18" charset="0"/>
+                <a:cs typeface="Times New Roman" panose="02020603050405020304" pitchFamily="18" charset="0"/>
+              </a:rPr>
               <a:t>WHO ARE THE END USERS?</a:t>
             </a:r>
-            <a:endParaRPr lang="en-IN" sz="2000" dirty="0"/>
+            <a:endParaRPr lang="en-IN" sz="4400" dirty="0">
+              <a:solidFill>
+                <a:srgbClr val="FF0000"/>
+              </a:solidFill>
+              <a:latin typeface="Times New Roman" panose="02020603050405020304" pitchFamily="18" charset="0"/>
+              <a:cs typeface="Times New Roman" panose="02020603050405020304" pitchFamily="18" charset="0"/>
+            </a:endParaRPr>
           </a:p>
         </p:txBody>
       </p:sp>
@@ -18301,7 +18363,7 @@
         <p:spPr>
           <a:xfrm>
             <a:off x="731520" y="1828800"/>
-            <a:ext cx="10515600" cy="3840480"/>
+            <a:ext cx="8879408" cy="3954929"/>
           </a:xfrm>
           <a:prstGeom prst="rect">
             <a:avLst/>
@@ -18314,93 +18376,127 @@
           </a:bodyPr>
           <a:lstStyle/>
           <a:p>
-            <a:pPr>
+            <a:pPr marL="342900" indent="-342900">
               <a:spcAft>
                 <a:spcPts val="1400"/>
               </a:spcAft>
+              <a:buFont typeface="+mj-lt"/>
+              <a:buAutoNum type="arabicPeriod"/>
             </a:pPr>
             <a:r>
-              <a:rPr b="1" sz="1400">
+              <a:rPr b="1" dirty="0">
                 <a:solidFill>
                   <a:srgbClr val="102C57"/>
                 </a:solidFill>
+                <a:latin typeface="Times New Roman" panose="02020603050405020304" pitchFamily="18" charset="0"/>
+                <a:cs typeface="Times New Roman" panose="02020603050405020304" pitchFamily="18" charset="0"/>
               </a:rPr>
-              <a:t>1. Farmers &amp; Agricultural Cooperatives: </a:t>
+              <a:t>Farmers &amp; Agricultural Cooperatives: </a:t>
             </a:r>
             <a:r>
-              <a:rPr b="0" sz="1300">
+              <a:rPr b="0" dirty="0">
                 <a:solidFill>
                   <a:srgbClr val="282828"/>
                 </a:solidFill>
+                <a:latin typeface="Times New Roman" panose="02020603050405020304" pitchFamily="18" charset="0"/>
+                <a:cs typeface="Times New Roman" panose="02020603050405020304" pitchFamily="18" charset="0"/>
               </a:rPr>
               <a:t>Provides actionable seasonal advisories for optimal crop selection, timing, and irrigation management (Drip vs. Flood) to maximize yield and net profit while minimizing production costs.</a:t>
             </a:r>
           </a:p>
           <a:p>
-            <a:pPr>
+            <a:pPr marL="342900" indent="-342900">
               <a:spcAft>
                 <a:spcPts val="1400"/>
               </a:spcAft>
+              <a:buFont typeface="+mj-lt"/>
+              <a:buAutoNum type="arabicPeriod"/>
             </a:pPr>
             <a:r>
-              <a:rPr b="1" sz="1400">
+              <a:rPr b="1" dirty="0">
                 <a:solidFill>
                   <a:srgbClr val="102C57"/>
                 </a:solidFill>
+                <a:latin typeface="Times New Roman" panose="02020603050405020304" pitchFamily="18" charset="0"/>
+                <a:cs typeface="Times New Roman" panose="02020603050405020304" pitchFamily="18" charset="0"/>
               </a:rPr>
-              <a:t>2. Agronomists &amp; Extension Officers: </a:t>
+              <a:t>Agronomists &amp; Extension Officers: </a:t>
             </a:r>
             <a:r>
-              <a:rPr b="0" sz="1300">
+              <a:rPr b="0" dirty="0">
                 <a:solidFill>
                   <a:srgbClr val="282828"/>
                 </a:solidFill>
+                <a:latin typeface="Times New Roman" panose="02020603050405020304" pitchFamily="18" charset="0"/>
+                <a:cs typeface="Times New Roman" panose="02020603050405020304" pitchFamily="18" charset="0"/>
               </a:rPr>
               <a:t>Empowers field officers with diagnostic tools to evaluate pest/disease vulnerabilities, soil nutrient requirements (N-P-K balance), and water efficiency metrics across varying seasons.</a:t>
             </a:r>
           </a:p>
           <a:p>
-            <a:pPr>
+            <a:pPr marL="342900" indent="-342900">
               <a:spcAft>
                 <a:spcPts val="1400"/>
               </a:spcAft>
+              <a:buFont typeface="+mj-lt"/>
+              <a:buAutoNum type="arabicPeriod"/>
             </a:pPr>
             <a:r>
-              <a:rPr b="1" sz="1400">
+              <a:rPr b="1" dirty="0">
                 <a:solidFill>
                   <a:srgbClr val="102C57"/>
                 </a:solidFill>
+                <a:latin typeface="Times New Roman" panose="02020603050405020304" pitchFamily="18" charset="0"/>
+                <a:cs typeface="Times New Roman" panose="02020603050405020304" pitchFamily="18" charset="0"/>
               </a:rPr>
-              <a:t>3. Government Agricultural Departments &amp; Policymakers: </a:t>
+              <a:t>Government Agricultural Departments &amp; Policymakers: </a:t>
             </a:r>
             <a:r>
-              <a:rPr b="0" sz="1300">
+              <a:rPr b="0" dirty="0">
                 <a:solidFill>
                   <a:srgbClr val="282828"/>
                 </a:solidFill>
+                <a:latin typeface="Times New Roman" panose="02020603050405020304" pitchFamily="18" charset="0"/>
+                <a:cs typeface="Times New Roman" panose="02020603050405020304" pitchFamily="18" charset="0"/>
               </a:rPr>
               <a:t>Enables evidence-based regional production forecasting, drought/flood contingency planning, and targeted water-subsidy resource allocation.</a:t>
             </a:r>
           </a:p>
           <a:p>
-            <a:pPr>
+            <a:pPr marL="342900" indent="-342900">
               <a:spcAft>
                 <a:spcPts val="1400"/>
               </a:spcAft>
+              <a:buFont typeface="+mj-lt"/>
+              <a:buAutoNum type="arabicPeriod"/>
             </a:pPr>
             <a:r>
-              <a:rPr b="1" sz="1400">
+              <a:rPr b="1" dirty="0" err="1">
                 <a:solidFill>
                   <a:srgbClr val="102C57"/>
                 </a:solidFill>
+                <a:latin typeface="Times New Roman" panose="02020603050405020304" pitchFamily="18" charset="0"/>
+                <a:cs typeface="Times New Roman" panose="02020603050405020304" pitchFamily="18" charset="0"/>
               </a:rPr>
-              <a:t>4. AgTech Companies &amp; Supply Chain Managers: </a:t>
+              <a:t>AgTech</a:t>
             </a:r>
             <a:r>
-              <a:rPr b="0" sz="1300">
+              <a:rPr b="1" dirty="0">
+                <a:solidFill>
+                  <a:srgbClr val="102C57"/>
+                </a:solidFill>
+                <a:latin typeface="Times New Roman" panose="02020603050405020304" pitchFamily="18" charset="0"/>
+                <a:cs typeface="Times New Roman" panose="02020603050405020304" pitchFamily="18" charset="0"/>
+              </a:rPr>
+              <a:t> Companies &amp; Supply Chain Managers: </a:t>
+            </a:r>
+            <a:r>
+              <a:rPr b="0" dirty="0">
                 <a:solidFill>
                   <a:srgbClr val="282828"/>
                 </a:solidFill>
+                <a:latin typeface="Times New Roman" panose="02020603050405020304" pitchFamily="18" charset="0"/>
+                <a:cs typeface="Times New Roman" panose="02020603050405020304" pitchFamily="18" charset="0"/>
               </a:rPr>
               <a:t>Delivers high-precision pre-harvest yield estimations to stabilize storage, logistics, food processing, and fair market procurement pricing.</a:t>
             </a:r>
@@ -18524,126 +18620,6 @@
                       </p:childTnLst>
                     </p:cTn>
                   </p:par>
-                  <p:par>
-                    <p:cTn id="10" fill="hold">
-                      <p:stCondLst>
-                        <p:cond delay="indefinite"/>
-                      </p:stCondLst>
-                      <p:childTnLst>
-                        <p:par>
-                          <p:cTn id="11" fill="hold">
-                            <p:stCondLst>
-                              <p:cond delay="0"/>
-                            </p:stCondLst>
-                            <p:childTnLst>
-                              <p:par>
-                                <p:cTn id="12" presetID="42" presetClass="entr" presetSubtype="0" fill="hold" grpId="0" nodeType="clickEffect" nodePh="1">
-                                  <p:stCondLst>
-                                    <p:cond delay="0"/>
-                                  </p:stCondLst>
-                                  <p:endCondLst>
-                                    <p:cond evt="begin" delay="0">
-                                      <p:tn val="12"/>
-                                    </p:cond>
-                                  </p:endCondLst>
-                                  <p:childTnLst>
-                                    <p:set>
-                                      <p:cBhvr>
-                                        <p:cTn id="13" dur="1" fill="hold">
-                                          <p:stCondLst>
-                                            <p:cond delay="0"/>
-                                          </p:stCondLst>
-                                        </p:cTn>
-                                        <p:tgtEl>
-                                          <p:spTgt spid="2">
-                                            <p:txEl>
-                                              <p:pRg st="0" end="0"/>
-                                            </p:txEl>
-                                          </p:spTgt>
-                                        </p:tgtEl>
-                                        <p:attrNameLst>
-                                          <p:attrName>style.visibility</p:attrName>
-                                        </p:attrNameLst>
-                                      </p:cBhvr>
-                                      <p:to>
-                                        <p:strVal val="visible"/>
-                                      </p:to>
-                                    </p:set>
-                                    <p:animEffect transition="in" filter="fade">
-                                      <p:cBhvr>
-                                        <p:cTn id="14" dur="1000"/>
-                                        <p:tgtEl>
-                                          <p:spTgt spid="2">
-                                            <p:txEl>
-                                              <p:pRg st="0" end="0"/>
-                                            </p:txEl>
-                                          </p:spTgt>
-                                        </p:tgtEl>
-                                      </p:cBhvr>
-                                    </p:animEffect>
-                                    <p:anim calcmode="lin" valueType="num">
-                                      <p:cBhvr>
-                                        <p:cTn id="15" dur="1000" fill="hold"/>
-                                        <p:tgtEl>
-                                          <p:spTgt spid="2">
-                                            <p:txEl>
-                                              <p:pRg st="0" end="0"/>
-                                            </p:txEl>
-                                          </p:spTgt>
-                                        </p:tgtEl>
-                                        <p:attrNameLst>
-                                          <p:attrName>ppt_x</p:attrName>
-                                        </p:attrNameLst>
-                                      </p:cBhvr>
-                                      <p:tavLst>
-                                        <p:tav tm="0">
-                                          <p:val>
-                                            <p:strVal val="#ppt_x"/>
-                                          </p:val>
-                                        </p:tav>
-                                        <p:tav tm="100000">
-                                          <p:val>
-                                            <p:strVal val="#ppt_x"/>
-                                          </p:val>
-                                        </p:tav>
-                                      </p:tavLst>
-                                    </p:anim>
-                                    <p:anim calcmode="lin" valueType="num">
-                                      <p:cBhvr>
-                                        <p:cTn id="16" dur="1000" fill="hold"/>
-                                        <p:tgtEl>
-                                          <p:spTgt spid="2">
-                                            <p:txEl>
-                                              <p:pRg st="0" end="0"/>
-                                            </p:txEl>
-                                          </p:spTgt>
-                                        </p:tgtEl>
-                                        <p:attrNameLst>
-                                          <p:attrName>ppt_y</p:attrName>
-                                        </p:attrNameLst>
-                                      </p:cBhvr>
-                                      <p:tavLst>
-                                        <p:tav tm="0">
-                                          <p:val>
-                                            <p:strVal val="#ppt_y+.1"/>
-                                          </p:val>
-                                        </p:tav>
-                                        <p:tav tm="100000">
-                                          <p:val>
-                                            <p:strVal val="#ppt_y"/>
-                                          </p:val>
-                                        </p:tav>
-                                      </p:tavLst>
-                                    </p:anim>
-                                  </p:childTnLst>
-                                </p:cTn>
-                              </p:par>
-                            </p:childTnLst>
-                          </p:cTn>
-                        </p:par>
-                      </p:childTnLst>
-                    </p:cTn>
-                  </p:par>
                 </p:childTnLst>
               </p:cTn>
               <p:prevCondLst>
@@ -18666,7 +18642,6 @@
       </p:par>
     </p:tnLst>
     <p:bldLst>
-      <p:bldP spid="2" grpId="0" build="p"/>
       <p:bldP spid="4" grpId="0"/>
     </p:bldLst>
   </p:timing>
@@ -18762,41 +18737,6 @@
       </p:pic>
       <p:sp>
         <p:nvSpPr>
-          <p:cNvPr id="7" name="Text Placeholder 6">
-            <a:extLst>
-              <a:ext uri="{FF2B5EF4-FFF2-40B4-BE49-F238E27FC236}">
-                <a16:creationId xmlns:a16="http://schemas.microsoft.com/office/drawing/2014/main" id="{B21C28F5-3CA3-4B78-B5C9-550C00BB3174}"/>
-              </a:ext>
-            </a:extLst>
-          </p:cNvPr>
-          <p:cNvSpPr>
-            <a:spLocks noGrp="1"/>
-          </p:cNvSpPr>
-          <p:nvPr>
-            <p:ph type="body" sz="quarter" idx="12"/>
-          </p:nvPr>
-        </p:nvSpPr>
-        <p:spPr>
-          <a:xfrm>
-            <a:off x="390618" y="1432560"/>
-            <a:ext cx="9027702" cy="5243448"/>
-          </a:xfrm>
-        </p:spPr>
-        <p:txBody>
-          <a:bodyPr/>
-          <a:lstStyle/>
-          <a:p>
-            <a:pPr lvl="1">
-              <a:lnSpc>
-                <a:spcPct val="150000"/>
-              </a:lnSpc>
-            </a:pPr>
-            <a:endParaRPr lang="en-IN" dirty="0"/>
-          </a:p>
-        </p:txBody>
-      </p:sp>
-      <p:sp>
-        <p:nvSpPr>
           <p:cNvPr id="9" name="Title 8">
             <a:extLst>
               <a:ext uri="{FF2B5EF4-FFF2-40B4-BE49-F238E27FC236}">
@@ -18814,7 +18754,7 @@
         <p:spPr>
           <a:xfrm>
             <a:off x="660399" y="430567"/>
-            <a:ext cx="5306291" cy="847817"/>
+            <a:ext cx="6139235" cy="847817"/>
           </a:xfrm>
         </p:spPr>
         <p:txBody>
@@ -18824,8 +18764,14 @@
           <a:lstStyle/>
           <a:p>
             <a:r>
-              <a:rPr lang="en-US" dirty="0"/>
-              <a:t>Technology Used</a:t>
+              <a:rPr lang="en-US" sz="4400" dirty="0">
+                <a:solidFill>
+                  <a:srgbClr val="FF0000"/>
+                </a:solidFill>
+                <a:latin typeface="Times New Roman" panose="02020603050405020304" pitchFamily="18" charset="0"/>
+                <a:cs typeface="Times New Roman" panose="02020603050405020304" pitchFamily="18" charset="0"/>
+              </a:rPr>
+              <a:t>TECHNOLOGY USED</a:t>
             </a:r>
           </a:p>
         </p:txBody>
@@ -18838,8 +18784,8 @@
         </p:nvSpPr>
         <p:spPr>
           <a:xfrm>
-            <a:off x="731520" y="1645920"/>
-            <a:ext cx="10515600" cy="4114800"/>
+            <a:off x="1546698" y="1520785"/>
+            <a:ext cx="8015591" cy="3570208"/>
           </a:xfrm>
           <a:prstGeom prst="rect">
             <a:avLst/>
@@ -18852,141 +18798,327 @@
           </a:bodyPr>
           <a:lstStyle/>
           <a:p>
-            <a:pPr>
+            <a:pPr marL="285750" indent="-285750">
               <a:spcAft>
                 <a:spcPts val="1200"/>
               </a:spcAft>
+              <a:buFont typeface="Wingdings" panose="05000000000000000000" pitchFamily="2" charset="2"/>
+              <a:buChar char="Ø"/>
             </a:pPr>
             <a:r>
-              <a:rPr b="1" sz="1400">
+              <a:rPr sz="1600" b="1" dirty="0">
                 <a:solidFill>
                   <a:srgbClr val="102C57"/>
                 </a:solidFill>
+                <a:latin typeface="Times New Roman" panose="02020603050405020304" pitchFamily="18" charset="0"/>
+                <a:cs typeface="Times New Roman" panose="02020603050405020304" pitchFamily="18" charset="0"/>
               </a:rPr>
               <a:t>• Programming Language: </a:t>
             </a:r>
             <a:r>
-              <a:rPr b="0" sz="1300">
+              <a:rPr sz="1600" b="0" dirty="0">
                 <a:solidFill>
                   <a:srgbClr val="282828"/>
                 </a:solidFill>
+                <a:latin typeface="Times New Roman" panose="02020603050405020304" pitchFamily="18" charset="0"/>
+                <a:cs typeface="Times New Roman" panose="02020603050405020304" pitchFamily="18" charset="0"/>
               </a:rPr>
               <a:t>Python 3.11+ (High performance data science &amp; ML runtime)</a:t>
             </a:r>
           </a:p>
           <a:p>
-            <a:pPr>
+            <a:pPr marL="285750" indent="-285750">
               <a:spcAft>
                 <a:spcPts val="1200"/>
               </a:spcAft>
+              <a:buFont typeface="Wingdings" panose="05000000000000000000" pitchFamily="2" charset="2"/>
+              <a:buChar char="Ø"/>
             </a:pPr>
             <a:r>
-              <a:rPr b="1" sz="1400">
+              <a:rPr sz="1600" b="1" dirty="0">
                 <a:solidFill>
                   <a:srgbClr val="102C57"/>
                 </a:solidFill>
+                <a:latin typeface="Times New Roman" panose="02020603050405020304" pitchFamily="18" charset="0"/>
+                <a:cs typeface="Times New Roman" panose="02020603050405020304" pitchFamily="18" charset="0"/>
               </a:rPr>
               <a:t>• Data Manipulation &amp; Wrangling: </a:t>
             </a:r>
             <a:r>
-              <a:rPr b="0" sz="1300">
+              <a:rPr sz="1600" b="0" dirty="0">
                 <a:solidFill>
                   <a:srgbClr val="282828"/>
                 </a:solidFill>
+                <a:latin typeface="Times New Roman" panose="02020603050405020304" pitchFamily="18" charset="0"/>
+                <a:cs typeface="Times New Roman" panose="02020603050405020304" pitchFamily="18" charset="0"/>
               </a:rPr>
-              <a:t>Pandas (DataFrame transformations, grouped aggregations), NumPy (Vectorized numerical computations)</a:t>
+              <a:t>Pandas (</a:t>
             </a:r>
-          </a:p>
-          <a:p>
-            <a:pPr>
+            <a:r>
+              <a:rPr sz="1600" b="0" dirty="0" err="1">
+                <a:solidFill>
+                  <a:srgbClr val="282828"/>
+                </a:solidFill>
+                <a:latin typeface="Times New Roman" panose="02020603050405020304" pitchFamily="18" charset="0"/>
+                <a:cs typeface="Times New Roman" panose="02020603050405020304" pitchFamily="18" charset="0"/>
+              </a:rPr>
+              <a:t>DataFrame</a:t>
+            </a:r>
+            <a:r>
+              <a:rPr sz="1600" b="0" dirty="0">
+                <a:solidFill>
+                  <a:srgbClr val="282828"/>
+                </a:solidFill>
+                <a:latin typeface="Times New Roman" panose="02020603050405020304" pitchFamily="18" charset="0"/>
+                <a:cs typeface="Times New Roman" panose="02020603050405020304" pitchFamily="18" charset="0"/>
+              </a:rPr>
+              <a:t> transformations, grouped aggregations), NumPy (Vectorized numerical computations)</a:t>
+            </a:r>
+          </a:p>
+          <a:p>
+            <a:pPr marL="285750" indent="-285750">
               <a:spcAft>
                 <a:spcPts val="1200"/>
               </a:spcAft>
+              <a:buFont typeface="Wingdings" panose="05000000000000000000" pitchFamily="2" charset="2"/>
+              <a:buChar char="Ø"/>
             </a:pPr>
             <a:r>
-              <a:rPr b="1" sz="1400">
+              <a:rPr sz="1600" b="1" dirty="0">
                 <a:solidFill>
                   <a:srgbClr val="102C57"/>
                 </a:solidFill>
+                <a:latin typeface="Times New Roman" panose="02020603050405020304" pitchFamily="18" charset="0"/>
+                <a:cs typeface="Times New Roman" panose="02020603050405020304" pitchFamily="18" charset="0"/>
               </a:rPr>
               <a:t>• Statistical Inference: </a:t>
             </a:r>
             <a:r>
-              <a:rPr b="0" sz="1300">
+              <a:rPr sz="1600" b="0" dirty="0">
                 <a:solidFill>
                   <a:srgbClr val="282828"/>
                 </a:solidFill>
+                <a:latin typeface="Times New Roman" panose="02020603050405020304" pitchFamily="18" charset="0"/>
+                <a:cs typeface="Times New Roman" panose="02020603050405020304" pitchFamily="18" charset="0"/>
               </a:rPr>
               <a:t>SciPy Stats (One-Way ANOVA hypothesis testing, p-value calculation, variance analysis)</a:t>
             </a:r>
           </a:p>
           <a:p>
-            <a:pPr>
+            <a:pPr marL="285750" indent="-285750">
               <a:spcAft>
                 <a:spcPts val="1200"/>
               </a:spcAft>
+              <a:buFont typeface="Wingdings" panose="05000000000000000000" pitchFamily="2" charset="2"/>
+              <a:buChar char="Ø"/>
             </a:pPr>
             <a:r>
-              <a:rPr b="1" sz="1400">
+              <a:rPr sz="1600" b="1" dirty="0">
                 <a:solidFill>
                   <a:srgbClr val="102C57"/>
                 </a:solidFill>
+                <a:latin typeface="Times New Roman" panose="02020603050405020304" pitchFamily="18" charset="0"/>
+                <a:cs typeface="Times New Roman" panose="02020603050405020304" pitchFamily="18" charset="0"/>
               </a:rPr>
               <a:t>• Machine Learning Frameworks: </a:t>
             </a:r>
             <a:r>
-              <a:rPr b="0" sz="1300">
+              <a:rPr sz="1600" b="0" dirty="0">
                 <a:solidFill>
                   <a:srgbClr val="282828"/>
                 </a:solidFill>
+                <a:latin typeface="Times New Roman" panose="02020603050405020304" pitchFamily="18" charset="0"/>
+                <a:cs typeface="Times New Roman" panose="02020603050405020304" pitchFamily="18" charset="0"/>
               </a:rPr>
-              <a:t>Scikit-Learn (Pipelines, ColumnTransformer, StandardScaler, OneHotEncoder, Ridge Regression, Random Forest, Gradient Boosting), XGBoost (Extreme Gradient Boosting Regressor &amp; Classifier)</a:t>
+              <a:t>Scikit-Learn (Pipelines, </a:t>
             </a:r>
-          </a:p>
-          <a:p>
-            <a:pPr>
+            <a:r>
+              <a:rPr sz="1600" b="0" dirty="0" err="1">
+                <a:solidFill>
+                  <a:srgbClr val="282828"/>
+                </a:solidFill>
+                <a:latin typeface="Times New Roman" panose="02020603050405020304" pitchFamily="18" charset="0"/>
+                <a:cs typeface="Times New Roman" panose="02020603050405020304" pitchFamily="18" charset="0"/>
+              </a:rPr>
+              <a:t>ColumnTransformer</a:t>
+            </a:r>
+            <a:r>
+              <a:rPr sz="1600" b="0" dirty="0">
+                <a:solidFill>
+                  <a:srgbClr val="282828"/>
+                </a:solidFill>
+                <a:latin typeface="Times New Roman" panose="02020603050405020304" pitchFamily="18" charset="0"/>
+                <a:cs typeface="Times New Roman" panose="02020603050405020304" pitchFamily="18" charset="0"/>
+              </a:rPr>
+              <a:t>, </a:t>
+            </a:r>
+            <a:r>
+              <a:rPr sz="1600" b="0" dirty="0" err="1">
+                <a:solidFill>
+                  <a:srgbClr val="282828"/>
+                </a:solidFill>
+                <a:latin typeface="Times New Roman" panose="02020603050405020304" pitchFamily="18" charset="0"/>
+                <a:cs typeface="Times New Roman" panose="02020603050405020304" pitchFamily="18" charset="0"/>
+              </a:rPr>
+              <a:t>StandardScaler</a:t>
+            </a:r>
+            <a:r>
+              <a:rPr sz="1600" b="0" dirty="0">
+                <a:solidFill>
+                  <a:srgbClr val="282828"/>
+                </a:solidFill>
+                <a:latin typeface="Times New Roman" panose="02020603050405020304" pitchFamily="18" charset="0"/>
+                <a:cs typeface="Times New Roman" panose="02020603050405020304" pitchFamily="18" charset="0"/>
+              </a:rPr>
+              <a:t>, </a:t>
+            </a:r>
+            <a:r>
+              <a:rPr sz="1600" b="0" dirty="0" err="1">
+                <a:solidFill>
+                  <a:srgbClr val="282828"/>
+                </a:solidFill>
+                <a:latin typeface="Times New Roman" panose="02020603050405020304" pitchFamily="18" charset="0"/>
+                <a:cs typeface="Times New Roman" panose="02020603050405020304" pitchFamily="18" charset="0"/>
+              </a:rPr>
+              <a:t>OneHotEncoder</a:t>
+            </a:r>
+            <a:r>
+              <a:rPr sz="1600" b="0" dirty="0">
+                <a:solidFill>
+                  <a:srgbClr val="282828"/>
+                </a:solidFill>
+                <a:latin typeface="Times New Roman" panose="02020603050405020304" pitchFamily="18" charset="0"/>
+                <a:cs typeface="Times New Roman" panose="02020603050405020304" pitchFamily="18" charset="0"/>
+              </a:rPr>
+              <a:t>, Ridge Regression, Random Forest, Gradient Boosting), </a:t>
+            </a:r>
+            <a:r>
+              <a:rPr sz="1600" b="0" dirty="0" err="1">
+                <a:solidFill>
+                  <a:srgbClr val="282828"/>
+                </a:solidFill>
+                <a:latin typeface="Times New Roman" panose="02020603050405020304" pitchFamily="18" charset="0"/>
+                <a:cs typeface="Times New Roman" panose="02020603050405020304" pitchFamily="18" charset="0"/>
+              </a:rPr>
+              <a:t>XGBoost</a:t>
+            </a:r>
+            <a:r>
+              <a:rPr sz="1600" b="0" dirty="0">
+                <a:solidFill>
+                  <a:srgbClr val="282828"/>
+                </a:solidFill>
+                <a:latin typeface="Times New Roman" panose="02020603050405020304" pitchFamily="18" charset="0"/>
+                <a:cs typeface="Times New Roman" panose="02020603050405020304" pitchFamily="18" charset="0"/>
+              </a:rPr>
+              <a:t> (Extreme Gradient Boosting Regressor &amp; Classifier)</a:t>
+            </a:r>
+          </a:p>
+          <a:p>
+            <a:pPr marL="285750" indent="-285750">
               <a:spcAft>
                 <a:spcPts val="1200"/>
               </a:spcAft>
+              <a:buFont typeface="Wingdings" panose="05000000000000000000" pitchFamily="2" charset="2"/>
+              <a:buChar char="Ø"/>
             </a:pPr>
             <a:r>
-              <a:rPr b="1" sz="1400">
+              <a:rPr sz="1600" b="1" dirty="0">
                 <a:solidFill>
                   <a:srgbClr val="102C57"/>
                 </a:solidFill>
+                <a:latin typeface="Times New Roman" panose="02020603050405020304" pitchFamily="18" charset="0"/>
+                <a:cs typeface="Times New Roman" panose="02020603050405020304" pitchFamily="18" charset="0"/>
               </a:rPr>
               <a:t>• Data Visualization &amp; Analytics: </a:t>
             </a:r>
             <a:r>
-              <a:rPr b="0" sz="1300">
+              <a:rPr sz="1600" b="0" dirty="0">
                 <a:solidFill>
                   <a:srgbClr val="282828"/>
                 </a:solidFill>
+                <a:latin typeface="Times New Roman" panose="02020603050405020304" pitchFamily="18" charset="0"/>
+                <a:cs typeface="Times New Roman" panose="02020603050405020304" pitchFamily="18" charset="0"/>
               </a:rPr>
               <a:t>Matplotlib &amp; Seaborn (High-resolution multi-panel plots, heatmaps, boxplots, residual scatter plots)</a:t>
             </a:r>
           </a:p>
           <a:p>
-            <a:pPr>
+            <a:pPr marL="285750" indent="-285750">
               <a:spcAft>
                 <a:spcPts val="1200"/>
               </a:spcAft>
+              <a:buFont typeface="Wingdings" panose="05000000000000000000" pitchFamily="2" charset="2"/>
+              <a:buChar char="Ø"/>
             </a:pPr>
             <a:r>
-              <a:rPr b="1" sz="1400">
+              <a:rPr sz="1600" b="1" dirty="0">
                 <a:solidFill>
                   <a:srgbClr val="102C57"/>
                 </a:solidFill>
+                <a:latin typeface="Times New Roman" panose="02020603050405020304" pitchFamily="18" charset="0"/>
+                <a:cs typeface="Times New Roman" panose="02020603050405020304" pitchFamily="18" charset="0"/>
               </a:rPr>
-              <a:t>• Model Serialization &amp; Reporting: </a:t>
+              <a:t>• Model Serialization: </a:t>
             </a:r>
             <a:r>
-              <a:rPr b="0" sz="1300">
+              <a:rPr sz="1600" b="0" dirty="0" err="1">
                 <a:solidFill>
                   <a:srgbClr val="282828"/>
                 </a:solidFill>
+                <a:latin typeface="Times New Roman" panose="02020603050405020304" pitchFamily="18" charset="0"/>
+                <a:cs typeface="Times New Roman" panose="02020603050405020304" pitchFamily="18" charset="0"/>
               </a:rPr>
-              <a:t>Joblib (Model persistence .joblib), Python-PPTX, Jupyter Notebook (.ipynb)</a:t>
+              <a:t>Joblib</a:t>
+            </a:r>
+            <a:r>
+              <a:rPr sz="1600" b="0" dirty="0">
+                <a:solidFill>
+                  <a:srgbClr val="282828"/>
+                </a:solidFill>
+                <a:latin typeface="Times New Roman" panose="02020603050405020304" pitchFamily="18" charset="0"/>
+                <a:cs typeface="Times New Roman" panose="02020603050405020304" pitchFamily="18" charset="0"/>
+              </a:rPr>
+              <a:t> (Model persistence .</a:t>
+            </a:r>
+            <a:r>
+              <a:rPr sz="1600" b="0" dirty="0" err="1">
+                <a:solidFill>
+                  <a:srgbClr val="282828"/>
+                </a:solidFill>
+                <a:latin typeface="Times New Roman" panose="02020603050405020304" pitchFamily="18" charset="0"/>
+                <a:cs typeface="Times New Roman" panose="02020603050405020304" pitchFamily="18" charset="0"/>
+              </a:rPr>
+              <a:t>joblib</a:t>
+            </a:r>
+            <a:r>
+              <a:rPr sz="1600" b="0" dirty="0">
+                <a:solidFill>
+                  <a:srgbClr val="282828"/>
+                </a:solidFill>
+                <a:latin typeface="Times New Roman" panose="02020603050405020304" pitchFamily="18" charset="0"/>
+                <a:cs typeface="Times New Roman" panose="02020603050405020304" pitchFamily="18" charset="0"/>
+              </a:rPr>
+              <a:t>), Jupyter Notebook (.</a:t>
+            </a:r>
+            <a:r>
+              <a:rPr sz="1600" b="0" dirty="0" err="1">
+                <a:solidFill>
+                  <a:srgbClr val="282828"/>
+                </a:solidFill>
+                <a:latin typeface="Times New Roman" panose="02020603050405020304" pitchFamily="18" charset="0"/>
+                <a:cs typeface="Times New Roman" panose="02020603050405020304" pitchFamily="18" charset="0"/>
+              </a:rPr>
+              <a:t>ipynb</a:t>
+            </a:r>
+            <a:r>
+              <a:rPr sz="1600" b="0" dirty="0">
+                <a:solidFill>
+                  <a:srgbClr val="282828"/>
+                </a:solidFill>
+                <a:latin typeface="Times New Roman" panose="02020603050405020304" pitchFamily="18" charset="0"/>
+                <a:cs typeface="Times New Roman" panose="02020603050405020304" pitchFamily="18" charset="0"/>
+              </a:rPr>
+              <a:t>)</a:t>
             </a:r>
           </a:p>
         </p:txBody>
@@ -19108,126 +19240,6 @@
                       </p:childTnLst>
                     </p:cTn>
                   </p:par>
-                  <p:par>
-                    <p:cTn id="10" fill="hold">
-                      <p:stCondLst>
-                        <p:cond delay="indefinite"/>
-                      </p:stCondLst>
-                      <p:childTnLst>
-                        <p:par>
-                          <p:cTn id="11" fill="hold">
-                            <p:stCondLst>
-                              <p:cond delay="0"/>
-                            </p:stCondLst>
-                            <p:childTnLst>
-                              <p:par>
-                                <p:cTn id="12" presetID="42" presetClass="entr" presetSubtype="0" fill="hold" grpId="0" nodeType="clickEffect" nodePh="1">
-                                  <p:stCondLst>
-                                    <p:cond delay="0"/>
-                                  </p:stCondLst>
-                                  <p:endCondLst>
-                                    <p:cond evt="begin" delay="0">
-                                      <p:tn val="12"/>
-                                    </p:cond>
-                                  </p:endCondLst>
-                                  <p:childTnLst>
-                                    <p:set>
-                                      <p:cBhvr>
-                                        <p:cTn id="13" dur="1" fill="hold">
-                                          <p:stCondLst>
-                                            <p:cond delay="0"/>
-                                          </p:stCondLst>
-                                        </p:cTn>
-                                        <p:tgtEl>
-                                          <p:spTgt spid="7">
-                                            <p:txEl>
-                                              <p:pRg st="0" end="0"/>
-                                            </p:txEl>
-                                          </p:spTgt>
-                                        </p:tgtEl>
-                                        <p:attrNameLst>
-                                          <p:attrName>style.visibility</p:attrName>
-                                        </p:attrNameLst>
-                                      </p:cBhvr>
-                                      <p:to>
-                                        <p:strVal val="visible"/>
-                                      </p:to>
-                                    </p:set>
-                                    <p:animEffect transition="in" filter="fade">
-                                      <p:cBhvr>
-                                        <p:cTn id="14" dur="1000"/>
-                                        <p:tgtEl>
-                                          <p:spTgt spid="7">
-                                            <p:txEl>
-                                              <p:pRg st="0" end="0"/>
-                                            </p:txEl>
-                                          </p:spTgt>
-                                        </p:tgtEl>
-                                      </p:cBhvr>
-                                    </p:animEffect>
-                                    <p:anim calcmode="lin" valueType="num">
-                                      <p:cBhvr>
-                                        <p:cTn id="15" dur="1000" fill="hold"/>
-                                        <p:tgtEl>
-                                          <p:spTgt spid="7">
-                                            <p:txEl>
-                                              <p:pRg st="0" end="0"/>
-                                            </p:txEl>
-                                          </p:spTgt>
-                                        </p:tgtEl>
-                                        <p:attrNameLst>
-                                          <p:attrName>ppt_x</p:attrName>
-                                        </p:attrNameLst>
-                                      </p:cBhvr>
-                                      <p:tavLst>
-                                        <p:tav tm="0">
-                                          <p:val>
-                                            <p:strVal val="#ppt_x"/>
-                                          </p:val>
-                                        </p:tav>
-                                        <p:tav tm="100000">
-                                          <p:val>
-                                            <p:strVal val="#ppt_x"/>
-                                          </p:val>
-                                        </p:tav>
-                                      </p:tavLst>
-                                    </p:anim>
-                                    <p:anim calcmode="lin" valueType="num">
-                                      <p:cBhvr>
-                                        <p:cTn id="16" dur="1000" fill="hold"/>
-                                        <p:tgtEl>
-                                          <p:spTgt spid="7">
-                                            <p:txEl>
-                                              <p:pRg st="0" end="0"/>
-                                            </p:txEl>
-                                          </p:spTgt>
-                                        </p:tgtEl>
-                                        <p:attrNameLst>
-                                          <p:attrName>ppt_y</p:attrName>
-                                        </p:attrNameLst>
-                                      </p:cBhvr>
-                                      <p:tavLst>
-                                        <p:tav tm="0">
-                                          <p:val>
-                                            <p:strVal val="#ppt_y+.1"/>
-                                          </p:val>
-                                        </p:tav>
-                                        <p:tav tm="100000">
-                                          <p:val>
-                                            <p:strVal val="#ppt_y"/>
-                                          </p:val>
-                                        </p:tav>
-                                      </p:tavLst>
-                                    </p:anim>
-                                  </p:childTnLst>
-                                </p:cTn>
-                              </p:par>
-                            </p:childTnLst>
-                          </p:cTn>
-                        </p:par>
-                      </p:childTnLst>
-                    </p:cTn>
-                  </p:par>
                 </p:childTnLst>
               </p:cTn>
               <p:prevCondLst>
@@ -19250,7 +19262,6 @@
       </p:par>
     </p:tnLst>
     <p:bldLst>
-      <p:bldP spid="7" grpId="0" build="p"/>
       <p:bldP spid="9" grpId="0"/>
     </p:bldLst>
   </p:timing>
@@ -19322,12 +19333,12 @@
         <p:spPr>
           <a:xfrm>
             <a:off x="675957" y="370589"/>
-            <a:ext cx="2981643" cy="830997"/>
+            <a:ext cx="8322128" cy="1205292"/>
           </a:xfrm>
         </p:spPr>
         <p:txBody>
           <a:bodyPr>
-            <a:normAutofit/>
+            <a:noAutofit/>
           </a:bodyPr>
           <a:lstStyle/>
           <a:p>
@@ -19339,7 +19350,14 @@
               </a:defRPr>
             </a:pPr>
             <a:r>
-              <a:t>RESULTS: Seasonal Yield &amp; Profitability Dynamics</a:t>
+              <a:rPr lang="en-US" sz="3600" dirty="0">
+                <a:solidFill>
+                  <a:srgbClr val="FF0000"/>
+                </a:solidFill>
+                <a:latin typeface="Times New Roman" panose="02020603050405020304" pitchFamily="18" charset="0"/>
+                <a:cs typeface="Times New Roman" panose="02020603050405020304" pitchFamily="18" charset="0"/>
+              </a:rPr>
+              <a:t>RESULTS: SEASONAL YIELD &amp; PROFITABILITY DYNAMICS</a:t>
             </a:r>
           </a:p>
         </p:txBody>
@@ -19872,8 +19890,8 @@
         </p:blipFill>
         <p:spPr>
           <a:xfrm>
-            <a:off x="731520" y="1645920"/>
-            <a:ext cx="5486400" cy="3931920"/>
+            <a:off x="516333" y="1645919"/>
+            <a:ext cx="5701587" cy="4086137"/>
           </a:xfrm>
           <a:prstGeom prst="rect">
             <a:avLst/>
@@ -19888,8 +19906,8 @@
         </p:nvSpPr>
         <p:spPr>
           <a:xfrm>
-            <a:off x="6492240" y="1645920"/>
-            <a:ext cx="5303520" cy="3931920"/>
+            <a:off x="6492239" y="2120915"/>
+            <a:ext cx="3196509" cy="4042132"/>
           </a:xfrm>
           <a:prstGeom prst="rect">
             <a:avLst/>
@@ -19908,18 +19926,22 @@
               </a:spcAft>
             </a:pPr>
             <a:r>
-              <a:rPr b="1" sz="1300">
+              <a:rPr sz="1600" b="1" dirty="0">
                 <a:solidFill>
                   <a:srgbClr val="102C57"/>
                 </a:solidFill>
+                <a:latin typeface="Times New Roman" panose="02020603050405020304" pitchFamily="18" charset="0"/>
+                <a:cs typeface="Times New Roman" panose="02020603050405020304" pitchFamily="18" charset="0"/>
               </a:rPr>
               <a:t>• Kharif Season: </a:t>
             </a:r>
             <a:r>
-              <a:rPr b="0" sz="1200">
+              <a:rPr sz="1600" b="0" dirty="0">
                 <a:solidFill>
                   <a:srgbClr val="282828"/>
                 </a:solidFill>
+                <a:latin typeface="Times New Roman" panose="02020603050405020304" pitchFamily="18" charset="0"/>
+                <a:cs typeface="Times New Roman" panose="02020603050405020304" pitchFamily="18" charset="0"/>
               </a:rPr>
               <a:t>Exhibits highest overall rainfall and moisture, supporting heavy crops but experiencing elevated disease/pest risks.</a:t>
             </a:r>
@@ -19931,18 +19953,22 @@
               </a:spcAft>
             </a:pPr>
             <a:r>
-              <a:rPr b="1" sz="1300">
+              <a:rPr sz="1600" b="1" dirty="0">
                 <a:solidFill>
                   <a:srgbClr val="102C57"/>
                 </a:solidFill>
+                <a:latin typeface="Times New Roman" panose="02020603050405020304" pitchFamily="18" charset="0"/>
+                <a:cs typeface="Times New Roman" panose="02020603050405020304" pitchFamily="18" charset="0"/>
               </a:rPr>
               <a:t>• Rabi Season: </a:t>
             </a:r>
             <a:r>
-              <a:rPr b="0" sz="1200">
+              <a:rPr sz="1600" b="0" dirty="0">
                 <a:solidFill>
                   <a:srgbClr val="282828"/>
                 </a:solidFill>
+                <a:latin typeface="Times New Roman" panose="02020603050405020304" pitchFamily="18" charset="0"/>
+                <a:cs typeface="Times New Roman" panose="02020603050405020304" pitchFamily="18" charset="0"/>
               </a:rPr>
               <a:t>Delivers optimal yield consistency and strong net profits, benefiting from controlled irrigation and favorable winter temperatures.</a:t>
             </a:r>
@@ -19954,18 +19980,22 @@
               </a:spcAft>
             </a:pPr>
             <a:r>
-              <a:rPr b="1" sz="1300">
+              <a:rPr sz="1600" b="1" dirty="0">
                 <a:solidFill>
                   <a:srgbClr val="102C57"/>
                 </a:solidFill>
+                <a:latin typeface="Times New Roman" panose="02020603050405020304" pitchFamily="18" charset="0"/>
+                <a:cs typeface="Times New Roman" panose="02020603050405020304" pitchFamily="18" charset="0"/>
               </a:rPr>
               <a:t>• Zaid Season: </a:t>
             </a:r>
             <a:r>
-              <a:rPr b="0" sz="1200">
+              <a:rPr sz="1600" b="0" dirty="0">
                 <a:solidFill>
                   <a:srgbClr val="282828"/>
                 </a:solidFill>
+                <a:latin typeface="Times New Roman" panose="02020603050405020304" pitchFamily="18" charset="0"/>
+                <a:cs typeface="Times New Roman" panose="02020603050405020304" pitchFamily="18" charset="0"/>
               </a:rPr>
               <a:t>Characterized by high ambient temperatures and dry conditions; profitability depends critically on high-efficiency irrigation methods.</a:t>
             </a:r>
@@ -20398,12 +20428,12 @@
         <p:spPr>
           <a:xfrm>
             <a:off x="675957" y="370589"/>
-            <a:ext cx="2981643" cy="830997"/>
+            <a:ext cx="7013298" cy="830997"/>
           </a:xfrm>
         </p:spPr>
         <p:txBody>
           <a:bodyPr>
-            <a:normAutofit/>
+            <a:normAutofit fontScale="90000"/>
           </a:bodyPr>
           <a:lstStyle/>
           <a:p>
@@ -20415,7 +20445,27 @@
               </a:defRPr>
             </a:pPr>
             <a:r>
-              <a:t>RESULTS: Crop Yield Prediction Model (R² = 0.990)</a:t>
+              <a:rPr sz="3600" dirty="0">
+                <a:solidFill>
+                  <a:srgbClr val="FF0000"/>
+                </a:solidFill>
+                <a:latin typeface="Times New Roman" panose="02020603050405020304" pitchFamily="18" charset="0"/>
+                <a:cs typeface="Times New Roman" panose="02020603050405020304" pitchFamily="18" charset="0"/>
+              </a:rPr>
+              <a:t>RESULTS: </a:t>
+            </a:r>
+            <a:br>
+              <a:rPr lang="en-US" sz="3600" dirty="0">
+                <a:solidFill>
+                  <a:srgbClr val="FF0000"/>
+                </a:solidFill>
+                <a:latin typeface="Times New Roman" panose="02020603050405020304" pitchFamily="18" charset="0"/>
+                <a:cs typeface="Times New Roman" panose="02020603050405020304" pitchFamily="18" charset="0"/>
+              </a:rPr>
+            </a:br>
+            <a:r>
+              <a:rPr dirty="0"/>
+              <a:t>Crop Yield Prediction Model (R² = 0.990)</a:t>
             </a:r>
           </a:p>
         </p:txBody>
@@ -20932,34 +20982,6 @@
           </a:p>
         </p:txBody>
       </p:sp>
-      <p:sp>
-        <p:nvSpPr>
-          <p:cNvPr id="10" name="Text Placeholder 1">
-            <a:extLst>
-              <a:ext uri="{FF2B5EF4-FFF2-40B4-BE49-F238E27FC236}">
-                <a16:creationId xmlns:a16="http://schemas.microsoft.com/office/drawing/2014/main" id="{3A64DB11-806F-1A4C-E0D5-D745D29CED50}"/>
-              </a:ext>
-            </a:extLst>
-          </p:cNvPr>
-          <p:cNvSpPr>
-            <a:spLocks noGrp="1"/>
-          </p:cNvSpPr>
-          <p:nvPr>
-            <p:ph type="body" sz="quarter" idx="12"/>
-          </p:nvPr>
-        </p:nvSpPr>
-        <p:spPr>
-          <a:xfrm>
-            <a:off x="807164" y="1431693"/>
-            <a:ext cx="4275138" cy="477520"/>
-          </a:xfrm>
-        </p:spPr>
-        <p:txBody>
-          <a:bodyPr/>
-          <a:lstStyle/>
-          <a:p/>
-        </p:txBody>
-      </p:sp>
       <p:pic>
         <p:nvPicPr>
           <p:cNvPr id="31" name="Picture 30" descr="model_actual_vs_predicted.png"/>
@@ -20976,7 +20998,7 @@
         </p:blipFill>
         <p:spPr>
           <a:xfrm>
-            <a:off x="731520" y="1645920"/>
+            <a:off x="324689" y="1645920"/>
             <a:ext cx="5486400" cy="3931920"/>
           </a:xfrm>
           <a:prstGeom prst="rect">
@@ -20992,8 +21014,8 @@
         </p:nvSpPr>
         <p:spPr>
           <a:xfrm>
-            <a:off x="6492240" y="1645920"/>
-            <a:ext cx="5303520" cy="3931920"/>
+            <a:off x="5811089" y="2029094"/>
+            <a:ext cx="3929782" cy="3303468"/>
           </a:xfrm>
           <a:prstGeom prst="rect">
             <a:avLst/>
@@ -21012,20 +21034,44 @@
               </a:spcAft>
             </a:pPr>
             <a:r>
-              <a:rPr b="1" sz="1300">
+              <a:rPr sz="1600" b="1" dirty="0">
                 <a:solidFill>
                   <a:srgbClr val="102C57"/>
                 </a:solidFill>
+                <a:latin typeface="Times New Roman" panose="02020603050405020304" pitchFamily="18" charset="0"/>
+                <a:cs typeface="Times New Roman" panose="02020603050405020304" pitchFamily="18" charset="0"/>
               </a:rPr>
               <a:t>• Algorithm Benchmarking: </a:t>
             </a:r>
             <a:r>
-              <a:rPr b="0" sz="1200">
+              <a:rPr sz="1600" b="0" dirty="0">
                 <a:solidFill>
                   <a:srgbClr val="282828"/>
                 </a:solidFill>
+                <a:latin typeface="Times New Roman" panose="02020603050405020304" pitchFamily="18" charset="0"/>
+                <a:cs typeface="Times New Roman" panose="02020603050405020304" pitchFamily="18" charset="0"/>
               </a:rPr>
-              <a:t>Compared Linear Regression, Ridge, Random Forest, Gradient Boosting, and XGBoost using 5-Fold Cross-Validation.</a:t>
+              <a:t>Compared Linear Regression, Ridge, Random Forest, Gradient Boosting, and </a:t>
+            </a:r>
+            <a:r>
+              <a:rPr sz="1600" b="0" dirty="0" err="1">
+                <a:solidFill>
+                  <a:srgbClr val="282828"/>
+                </a:solidFill>
+                <a:latin typeface="Times New Roman" panose="02020603050405020304" pitchFamily="18" charset="0"/>
+                <a:cs typeface="Times New Roman" panose="02020603050405020304" pitchFamily="18" charset="0"/>
+              </a:rPr>
+              <a:t>XGBoost</a:t>
+            </a:r>
+            <a:r>
+              <a:rPr sz="1600" b="0" dirty="0">
+                <a:solidFill>
+                  <a:srgbClr val="282828"/>
+                </a:solidFill>
+                <a:latin typeface="Times New Roman" panose="02020603050405020304" pitchFamily="18" charset="0"/>
+                <a:cs typeface="Times New Roman" panose="02020603050405020304" pitchFamily="18" charset="0"/>
+              </a:rPr>
+              <a:t> using 5-Fold Cross-Validation.</a:t>
             </a:r>
           </a:p>
           <a:p>
@@ -21035,20 +21081,64 @@
               </a:spcAft>
             </a:pPr>
             <a:r>
-              <a:rPr b="1" sz="1300">
+              <a:rPr sz="1600" b="1" dirty="0">
                 <a:solidFill>
                   <a:srgbClr val="102C57"/>
                 </a:solidFill>
+                <a:latin typeface="Times New Roman" panose="02020603050405020304" pitchFamily="18" charset="0"/>
+                <a:cs typeface="Times New Roman" panose="02020603050405020304" pitchFamily="18" charset="0"/>
               </a:rPr>
               <a:t>• Top Performer: </a:t>
             </a:r>
             <a:r>
-              <a:rPr b="0" sz="1200">
+              <a:rPr sz="1600" b="0" dirty="0">
                 <a:solidFill>
                   <a:srgbClr val="282828"/>
                 </a:solidFill>
+                <a:latin typeface="Times New Roman" panose="02020603050405020304" pitchFamily="18" charset="0"/>
+                <a:cs typeface="Times New Roman" panose="02020603050405020304" pitchFamily="18" charset="0"/>
               </a:rPr>
-              <a:t>Gradient Boosting achieved an extraordinary R² of 0.9900, MAE of 0.4636 Tonnes/Ha, and RMSE of 1.3899 Tonnes/Ha.</a:t>
+              <a:t>Gradient Boosting achieved an extraordinary R² of 0.9900, MAE of 0.4636 </a:t>
+            </a:r>
+            <a:r>
+              <a:rPr sz="1600" b="0" dirty="0" err="1">
+                <a:solidFill>
+                  <a:srgbClr val="282828"/>
+                </a:solidFill>
+                <a:latin typeface="Times New Roman" panose="02020603050405020304" pitchFamily="18" charset="0"/>
+                <a:cs typeface="Times New Roman" panose="02020603050405020304" pitchFamily="18" charset="0"/>
+              </a:rPr>
+              <a:t>Tonnes</a:t>
+            </a:r>
+            <a:r>
+              <a:rPr sz="1600" b="0" dirty="0">
+                <a:solidFill>
+                  <a:srgbClr val="282828"/>
+                </a:solidFill>
+                <a:latin typeface="Times New Roman" panose="02020603050405020304" pitchFamily="18" charset="0"/>
+                <a:cs typeface="Times New Roman" panose="02020603050405020304" pitchFamily="18" charset="0"/>
+              </a:rPr>
+              <a:t>/Ha, and RMSE of 1.3899 </a:t>
+            </a:r>
+            <a:r>
+              <a:rPr sz="1600" b="0" dirty="0" err="1">
+                <a:solidFill>
+                  <a:srgbClr val="282828"/>
+                </a:solidFill>
+                <a:latin typeface="Times New Roman" panose="02020603050405020304" pitchFamily="18" charset="0"/>
+                <a:cs typeface="Times New Roman" panose="02020603050405020304" pitchFamily="18" charset="0"/>
+              </a:rPr>
+              <a:t>Tonnes</a:t>
+            </a:r>
+            <a:r>
+              <a:rPr sz="1600" b="0" dirty="0">
+                <a:solidFill>
+                  <a:srgbClr val="282828"/>
+                </a:solidFill>
+                <a:latin typeface="Times New Roman" panose="02020603050405020304" pitchFamily="18" charset="0"/>
+                <a:cs typeface="Times New Roman" panose="02020603050405020304" pitchFamily="18" charset="0"/>
+              </a:rPr>
+              <a:t>/Ha.</a:t>
             </a:r>
           </a:p>
           <a:p>
@@ -21058,18 +21148,22 @@
               </a:spcAft>
             </a:pPr>
             <a:r>
-              <a:rPr b="1" sz="1300">
+              <a:rPr sz="1600" b="1" dirty="0">
                 <a:solidFill>
                   <a:srgbClr val="102C57"/>
                 </a:solidFill>
+                <a:latin typeface="Times New Roman" panose="02020603050405020304" pitchFamily="18" charset="0"/>
+                <a:cs typeface="Times New Roman" panose="02020603050405020304" pitchFamily="18" charset="0"/>
               </a:rPr>
               <a:t>• Validation Quality: </a:t>
             </a:r>
             <a:r>
-              <a:rPr b="0" sz="1200">
+              <a:rPr sz="1600" b="0" dirty="0">
                 <a:solidFill>
                   <a:srgbClr val="282828"/>
                 </a:solidFill>
+                <a:latin typeface="Times New Roman" panose="02020603050405020304" pitchFamily="18" charset="0"/>
+                <a:cs typeface="Times New Roman" panose="02020603050405020304" pitchFamily="18" charset="0"/>
               </a:rPr>
               <a:t>Actual vs. Predicted scatter plot demonstrates tight alignment along the 1:1 diagonal across all yield distributions.</a:t>
             </a:r>
@@ -21401,121 +21495,6 @@
                       </p:childTnLst>
                     </p:cTn>
                   </p:par>
-                  <p:par>
-                    <p:cTn id="24" fill="hold">
-                      <p:stCondLst>
-                        <p:cond delay="indefinite"/>
-                      </p:stCondLst>
-                      <p:childTnLst>
-                        <p:par>
-                          <p:cTn id="25" fill="hold">
-                            <p:stCondLst>
-                              <p:cond delay="0"/>
-                            </p:stCondLst>
-                            <p:childTnLst>
-                              <p:par>
-                                <p:cTn id="26" presetID="42" presetClass="entr" presetSubtype="0" fill="hold" grpId="0" nodeType="clickEffect">
-                                  <p:stCondLst>
-                                    <p:cond delay="0"/>
-                                  </p:stCondLst>
-                                  <p:childTnLst>
-                                    <p:set>
-                                      <p:cBhvr>
-                                        <p:cTn id="27" dur="1" fill="hold">
-                                          <p:stCondLst>
-                                            <p:cond delay="0"/>
-                                          </p:stCondLst>
-                                        </p:cTn>
-                                        <p:tgtEl>
-                                          <p:spTgt spid="10">
-                                            <p:txEl>
-                                              <p:pRg st="0" end="0"/>
-                                            </p:txEl>
-                                          </p:spTgt>
-                                        </p:tgtEl>
-                                        <p:attrNameLst>
-                                          <p:attrName>style.visibility</p:attrName>
-                                        </p:attrNameLst>
-                                      </p:cBhvr>
-                                      <p:to>
-                                        <p:strVal val="visible"/>
-                                      </p:to>
-                                    </p:set>
-                                    <p:animEffect transition="in" filter="fade">
-                                      <p:cBhvr>
-                                        <p:cTn id="28" dur="1000"/>
-                                        <p:tgtEl>
-                                          <p:spTgt spid="10">
-                                            <p:txEl>
-                                              <p:pRg st="0" end="0"/>
-                                            </p:txEl>
-                                          </p:spTgt>
-                                        </p:tgtEl>
-                                      </p:cBhvr>
-                                    </p:animEffect>
-                                    <p:anim calcmode="lin" valueType="num">
-                                      <p:cBhvr>
-                                        <p:cTn id="29" dur="1000" fill="hold"/>
-                                        <p:tgtEl>
-                                          <p:spTgt spid="10">
-                                            <p:txEl>
-                                              <p:pRg st="0" end="0"/>
-                                            </p:txEl>
-                                          </p:spTgt>
-                                        </p:tgtEl>
-                                        <p:attrNameLst>
-                                          <p:attrName>ppt_x</p:attrName>
-                                        </p:attrNameLst>
-                                      </p:cBhvr>
-                                      <p:tavLst>
-                                        <p:tav tm="0">
-                                          <p:val>
-                                            <p:strVal val="#ppt_x"/>
-                                          </p:val>
-                                        </p:tav>
-                                        <p:tav tm="100000">
-                                          <p:val>
-                                            <p:strVal val="#ppt_x"/>
-                                          </p:val>
-                                        </p:tav>
-                                      </p:tavLst>
-                                    </p:anim>
-                                    <p:anim calcmode="lin" valueType="num">
-                                      <p:cBhvr>
-                                        <p:cTn id="30" dur="1000" fill="hold"/>
-                                        <p:tgtEl>
-                                          <p:spTgt spid="10">
-                                            <p:txEl>
-                                              <p:pRg st="0" end="0"/>
-                                            </p:txEl>
-                                          </p:spTgt>
-                                        </p:tgtEl>
-                                        <p:attrNameLst>
-                                          <p:attrName>ppt_y</p:attrName>
-                                        </p:attrNameLst>
-                                      </p:cBhvr>
-                                      <p:tavLst>
-                                        <p:tav tm="0">
-                                          <p:val>
-                                            <p:strVal val="#ppt_y+.1"/>
-                                          </p:val>
-                                        </p:tav>
-                                        <p:tav tm="100000">
-                                          <p:val>
-                                            <p:strVal val="#ppt_y"/>
-                                          </p:val>
-                                        </p:tav>
-                                      </p:tavLst>
-                                    </p:anim>
-                                  </p:childTnLst>
-                                </p:cTn>
-                              </p:par>
-                            </p:childTnLst>
-                          </p:cTn>
-                        </p:par>
-                      </p:childTnLst>
-                    </p:cTn>
-                  </p:par>
                 </p:childTnLst>
               </p:cTn>
               <p:prevCondLst>
@@ -21541,7 +21520,6 @@
       <p:bldP spid="4" grpId="0"/>
       <p:bldP spid="7" grpId="0"/>
       <p:bldP spid="8" grpId="0"/>
-      <p:bldP spid="10" grpId="0" build="p"/>
     </p:bldLst>
   </p:timing>
 </p:sld>
@@ -21618,12 +21596,12 @@
         <p:spPr>
           <a:xfrm>
             <a:off x="675957" y="370589"/>
-            <a:ext cx="2981643" cy="830997"/>
+            <a:ext cx="7670375" cy="830997"/>
           </a:xfrm>
         </p:spPr>
         <p:txBody>
           <a:bodyPr>
-            <a:normAutofit/>
+            <a:normAutofit fontScale="90000"/>
           </a:bodyPr>
           <a:lstStyle/>
           <a:p>
@@ -21635,7 +21613,21 @@
               </a:defRPr>
             </a:pPr>
             <a:r>
-              <a:t>RESULTS: Feature Drivers &amp; Farm Profitability Model</a:t>
+              <a:rPr sz="4000" dirty="0">
+                <a:solidFill>
+                  <a:srgbClr val="FF0000"/>
+                </a:solidFill>
+                <a:latin typeface="Times New Roman" panose="02020603050405020304" pitchFamily="18" charset="0"/>
+                <a:cs typeface="Times New Roman" panose="02020603050405020304" pitchFamily="18" charset="0"/>
+              </a:rPr>
+              <a:t>RESULTS: </a:t>
+            </a:r>
+            <a:br>
+              <a:rPr lang="en-US" sz="4000" dirty="0"/>
+            </a:br>
+            <a:r>
+              <a:rPr dirty="0"/>
+              <a:t>Feature Drivers &amp; Farm Profitability Model</a:t>
             </a:r>
           </a:p>
         </p:txBody>
@@ -22152,34 +22144,6 @@
           </a:p>
         </p:txBody>
       </p:sp>
-      <p:sp>
-        <p:nvSpPr>
-          <p:cNvPr id="10" name="Text Placeholder 1">
-            <a:extLst>
-              <a:ext uri="{FF2B5EF4-FFF2-40B4-BE49-F238E27FC236}">
-                <a16:creationId xmlns:a16="http://schemas.microsoft.com/office/drawing/2014/main" id="{B6E3B1C7-6A8B-23EE-6251-DC1067C6ADE9}"/>
-              </a:ext>
-            </a:extLst>
-          </p:cNvPr>
-          <p:cNvSpPr>
-            <a:spLocks noGrp="1"/>
-          </p:cNvSpPr>
-          <p:nvPr>
-            <p:ph type="body" sz="quarter" idx="12"/>
-          </p:nvPr>
-        </p:nvSpPr>
-        <p:spPr>
-          <a:xfrm>
-            <a:off x="807164" y="1431693"/>
-            <a:ext cx="4275138" cy="477520"/>
-          </a:xfrm>
-        </p:spPr>
-        <p:txBody>
-          <a:bodyPr/>
-          <a:lstStyle/>
-          <a:p/>
-        </p:txBody>
-      </p:sp>
       <p:pic>
         <p:nvPicPr>
           <p:cNvPr id="31" name="Picture 30" descr="feature_importance_yield.png"/>
@@ -22196,7 +22160,7 @@
         </p:blipFill>
         <p:spPr>
           <a:xfrm>
-            <a:off x="731520" y="1645920"/>
+            <a:off x="324689" y="1645920"/>
             <a:ext cx="5486400" cy="3931920"/>
           </a:xfrm>
           <a:prstGeom prst="rect">
@@ -22212,8 +22176,8 @@
         </p:nvSpPr>
         <p:spPr>
           <a:xfrm>
-            <a:off x="6492240" y="1645920"/>
-            <a:ext cx="5303520" cy="3931920"/>
+            <a:off x="5811089" y="2105526"/>
+            <a:ext cx="4377447" cy="2811026"/>
           </a:xfrm>
           <a:prstGeom prst="rect">
             <a:avLst/>
@@ -22232,18 +22196,22 @@
               </a:spcAft>
             </a:pPr>
             <a:r>
-              <a:rPr b="1" sz="1300">
+              <a:rPr sz="1600" b="1" dirty="0">
                 <a:solidFill>
                   <a:srgbClr val="102C57"/>
                 </a:solidFill>
+                <a:latin typeface="Times New Roman" panose="02020603050405020304" pitchFamily="18" charset="0"/>
+                <a:cs typeface="Times New Roman" panose="02020603050405020304" pitchFamily="18" charset="0"/>
               </a:rPr>
               <a:t>• Primary Yield Drivers: </a:t>
             </a:r>
             <a:r>
-              <a:rPr b="0" sz="1200">
+              <a:rPr sz="1600" b="0" dirty="0">
                 <a:solidFill>
                   <a:srgbClr val="282828"/>
                 </a:solidFill>
+                <a:latin typeface="Times New Roman" panose="02020603050405020304" pitchFamily="18" charset="0"/>
+                <a:cs typeface="Times New Roman" panose="02020603050405020304" pitchFamily="18" charset="0"/>
               </a:rPr>
               <a:t>Crop variety, Seed Quality Score, and balanced N-P-K soil fertilization emerged as the most critical determinants of yield.</a:t>
             </a:r>
@@ -22255,20 +22223,34 @@
               </a:spcAft>
             </a:pPr>
             <a:r>
-              <a:rPr b="1" sz="1300">
+              <a:rPr sz="1600" b="1" dirty="0">
                 <a:solidFill>
                   <a:srgbClr val="102C57"/>
                 </a:solidFill>
+                <a:latin typeface="Times New Roman" panose="02020603050405020304" pitchFamily="18" charset="0"/>
+                <a:cs typeface="Times New Roman" panose="02020603050405020304" pitchFamily="18" charset="0"/>
               </a:rPr>
               <a:t>• Profitability Classifier: </a:t>
             </a:r>
             <a:r>
-              <a:rPr b="0" sz="1200">
+              <a:rPr sz="1600" b="0" dirty="0" err="1">
                 <a:solidFill>
                   <a:srgbClr val="282828"/>
                 </a:solidFill>
+                <a:latin typeface="Times New Roman" panose="02020603050405020304" pitchFamily="18" charset="0"/>
+                <a:cs typeface="Times New Roman" panose="02020603050405020304" pitchFamily="18" charset="0"/>
               </a:rPr>
-              <a:t>XGBoost Classifier predicted farm profitability with 92.25% Accuracy, 0.9242 F1-Score, and 0.9808 ROC-AUC.</a:t>
+              <a:t>XGBoost</a:t>
+            </a:r>
+            <a:r>
+              <a:rPr sz="1600" b="0" dirty="0">
+                <a:solidFill>
+                  <a:srgbClr val="282828"/>
+                </a:solidFill>
+                <a:latin typeface="Times New Roman" panose="02020603050405020304" pitchFamily="18" charset="0"/>
+                <a:cs typeface="Times New Roman" panose="02020603050405020304" pitchFamily="18" charset="0"/>
+              </a:rPr>
+              <a:t> Classifier predicted farm profitability with 92.25% Accuracy, 0.9242 F1-Score, and 0.9808 ROC-AUC.</a:t>
             </a:r>
           </a:p>
           <a:p>
@@ -22278,18 +22260,22 @@
               </a:spcAft>
             </a:pPr>
             <a:r>
-              <a:rPr b="1" sz="1300">
+              <a:rPr sz="1600" b="1" dirty="0">
                 <a:solidFill>
                   <a:srgbClr val="102C57"/>
                 </a:solidFill>
+                <a:latin typeface="Times New Roman" panose="02020603050405020304" pitchFamily="18" charset="0"/>
+                <a:cs typeface="Times New Roman" panose="02020603050405020304" pitchFamily="18" charset="0"/>
               </a:rPr>
               <a:t>• Practical Impact: </a:t>
             </a:r>
             <a:r>
-              <a:rPr b="0" sz="1200">
+              <a:rPr sz="1600" b="0" dirty="0">
                 <a:solidFill>
                   <a:srgbClr val="282828"/>
                 </a:solidFill>
+                <a:latin typeface="Times New Roman" panose="02020603050405020304" pitchFamily="18" charset="0"/>
+                <a:cs typeface="Times New Roman" panose="02020603050405020304" pitchFamily="18" charset="0"/>
               </a:rPr>
               <a:t>Enables pre-season financial feasibility assessments before farmers invest capital in seeds and fertilizers.</a:t>
             </a:r>
@@ -22621,121 +22607,6 @@
                       </p:childTnLst>
                     </p:cTn>
                   </p:par>
-                  <p:par>
-                    <p:cTn id="24" fill="hold">
-                      <p:stCondLst>
-                        <p:cond delay="indefinite"/>
-                      </p:stCondLst>
-                      <p:childTnLst>
-                        <p:par>
-                          <p:cTn id="25" fill="hold">
-                            <p:stCondLst>
-                              <p:cond delay="0"/>
-                            </p:stCondLst>
-                            <p:childTnLst>
-                              <p:par>
-                                <p:cTn id="26" presetID="42" presetClass="entr" presetSubtype="0" fill="hold" grpId="0" nodeType="clickEffect">
-                                  <p:stCondLst>
-                                    <p:cond delay="0"/>
-                                  </p:stCondLst>
-                                  <p:childTnLst>
-                                    <p:set>
-                                      <p:cBhvr>
-                                        <p:cTn id="27" dur="1" fill="hold">
-                                          <p:stCondLst>
-                                            <p:cond delay="0"/>
-                                          </p:stCondLst>
-                                        </p:cTn>
-                                        <p:tgtEl>
-                                          <p:spTgt spid="10">
-                                            <p:txEl>
-                                              <p:pRg st="0" end="0"/>
-                                            </p:txEl>
-                                          </p:spTgt>
-                                        </p:tgtEl>
-                                        <p:attrNameLst>
-                                          <p:attrName>style.visibility</p:attrName>
-                                        </p:attrNameLst>
-                                      </p:cBhvr>
-                                      <p:to>
-                                        <p:strVal val="visible"/>
-                                      </p:to>
-                                    </p:set>
-                                    <p:animEffect transition="in" filter="fade">
-                                      <p:cBhvr>
-                                        <p:cTn id="28" dur="1000"/>
-                                        <p:tgtEl>
-                                          <p:spTgt spid="10">
-                                            <p:txEl>
-                                              <p:pRg st="0" end="0"/>
-                                            </p:txEl>
-                                          </p:spTgt>
-                                        </p:tgtEl>
-                                      </p:cBhvr>
-                                    </p:animEffect>
-                                    <p:anim calcmode="lin" valueType="num">
-                                      <p:cBhvr>
-                                        <p:cTn id="29" dur="1000" fill="hold"/>
-                                        <p:tgtEl>
-                                          <p:spTgt spid="10">
-                                            <p:txEl>
-                                              <p:pRg st="0" end="0"/>
-                                            </p:txEl>
-                                          </p:spTgt>
-                                        </p:tgtEl>
-                                        <p:attrNameLst>
-                                          <p:attrName>ppt_x</p:attrName>
-                                        </p:attrNameLst>
-                                      </p:cBhvr>
-                                      <p:tavLst>
-                                        <p:tav tm="0">
-                                          <p:val>
-                                            <p:strVal val="#ppt_x"/>
-                                          </p:val>
-                                        </p:tav>
-                                        <p:tav tm="100000">
-                                          <p:val>
-                                            <p:strVal val="#ppt_x"/>
-                                          </p:val>
-                                        </p:tav>
-                                      </p:tavLst>
-                                    </p:anim>
-                                    <p:anim calcmode="lin" valueType="num">
-                                      <p:cBhvr>
-                                        <p:cTn id="30" dur="1000" fill="hold"/>
-                                        <p:tgtEl>
-                                          <p:spTgt spid="10">
-                                            <p:txEl>
-                                              <p:pRg st="0" end="0"/>
-                                            </p:txEl>
-                                          </p:spTgt>
-                                        </p:tgtEl>
-                                        <p:attrNameLst>
-                                          <p:attrName>ppt_y</p:attrName>
-                                        </p:attrNameLst>
-                                      </p:cBhvr>
-                                      <p:tavLst>
-                                        <p:tav tm="0">
-                                          <p:val>
-                                            <p:strVal val="#ppt_y+.1"/>
-                                          </p:val>
-                                        </p:tav>
-                                        <p:tav tm="100000">
-                                          <p:val>
-                                            <p:strVal val="#ppt_y"/>
-                                          </p:val>
-                                        </p:tav>
-                                      </p:tavLst>
-                                    </p:anim>
-                                  </p:childTnLst>
-                                </p:cTn>
-                              </p:par>
-                            </p:childTnLst>
-                          </p:cTn>
-                        </p:par>
-                      </p:childTnLst>
-                    </p:cTn>
-                  </p:par>
                 </p:childTnLst>
               </p:cTn>
               <p:prevCondLst>
@@ -22761,7 +22632,6 @@
       <p:bldP spid="4" grpId="0"/>
       <p:bldP spid="7" grpId="0"/>
       <p:bldP spid="8" grpId="0"/>
-      <p:bldP spid="10" grpId="0" build="p"/>
     </p:bldLst>
   </p:timing>
 </p:sld>
@@ -22838,12 +22708,12 @@
         <p:spPr>
           <a:xfrm>
             <a:off x="675957" y="370589"/>
-            <a:ext cx="2981643" cy="830997"/>
+            <a:ext cx="7013298" cy="830997"/>
           </a:xfrm>
         </p:spPr>
         <p:txBody>
           <a:bodyPr>
-            <a:normAutofit/>
+            <a:normAutofit fontScale="90000"/>
           </a:bodyPr>
           <a:lstStyle/>
           <a:p>
@@ -22855,7 +22725,21 @@
               </a:defRPr>
             </a:pPr>
             <a:r>
-              <a:t>RESULTS: Irrigation Technology &amp; Water Efficiency</a:t>
+              <a:rPr sz="4900" dirty="0">
+                <a:solidFill>
+                  <a:srgbClr val="FF0000"/>
+                </a:solidFill>
+                <a:latin typeface="Times New Roman" panose="02020603050405020304" pitchFamily="18" charset="0"/>
+                <a:cs typeface="Times New Roman" panose="02020603050405020304" pitchFamily="18" charset="0"/>
+              </a:rPr>
+              <a:t>RESULTS: </a:t>
+            </a:r>
+            <a:br>
+              <a:rPr lang="en-US" dirty="0"/>
+            </a:br>
+            <a:r>
+              <a:rPr dirty="0"/>
+              <a:t>Irrigation Technology &amp; Water Efficiency</a:t>
             </a:r>
           </a:p>
         </p:txBody>
@@ -23372,34 +23256,6 @@
           </a:p>
         </p:txBody>
       </p:sp>
-      <p:sp>
-        <p:nvSpPr>
-          <p:cNvPr id="10" name="Text Placeholder 1">
-            <a:extLst>
-              <a:ext uri="{FF2B5EF4-FFF2-40B4-BE49-F238E27FC236}">
-                <a16:creationId xmlns:a16="http://schemas.microsoft.com/office/drawing/2014/main" id="{2B7B89A1-9444-8322-CADC-42D31D698FA8}"/>
-              </a:ext>
-            </a:extLst>
-          </p:cNvPr>
-          <p:cNvSpPr>
-            <a:spLocks noGrp="1"/>
-          </p:cNvSpPr>
-          <p:nvPr>
-            <p:ph type="body" sz="quarter" idx="12"/>
-          </p:nvPr>
-        </p:nvSpPr>
-        <p:spPr>
-          <a:xfrm>
-            <a:off x="807164" y="1431693"/>
-            <a:ext cx="4275138" cy="477520"/>
-          </a:xfrm>
-        </p:spPr>
-        <p:txBody>
-          <a:bodyPr/>
-          <a:lstStyle/>
-          <a:p/>
-        </p:txBody>
-      </p:sp>
       <p:pic>
         <p:nvPicPr>
           <p:cNvPr id="31" name="Picture 30" descr="irrigation_water_efficiency.png"/>
@@ -23416,7 +23272,7 @@
         </p:blipFill>
         <p:spPr>
           <a:xfrm>
-            <a:off x="731520" y="1645920"/>
+            <a:off x="320982" y="1650709"/>
             <a:ext cx="5486400" cy="3931920"/>
           </a:xfrm>
           <a:prstGeom prst="rect">
@@ -23432,8 +23288,8 @@
         </p:nvSpPr>
         <p:spPr>
           <a:xfrm>
-            <a:off x="6492240" y="1645920"/>
-            <a:ext cx="5303520" cy="3931920"/>
+            <a:off x="6307415" y="1943395"/>
+            <a:ext cx="3770441" cy="3303468"/>
           </a:xfrm>
           <a:prstGeom prst="rect">
             <a:avLst/>
@@ -23452,20 +23308,44 @@
               </a:spcAft>
             </a:pPr>
             <a:r>
-              <a:rPr b="1" sz="1300">
+              <a:rPr sz="1600" b="1" dirty="0">
                 <a:solidFill>
                   <a:srgbClr val="102C57"/>
                 </a:solidFill>
+                <a:latin typeface="Times New Roman" panose="02020603050405020304" pitchFamily="18" charset="0"/>
+                <a:cs typeface="Times New Roman" panose="02020603050405020304" pitchFamily="18" charset="0"/>
               </a:rPr>
               <a:t>• Drip Irrigation Superiority: </a:t>
             </a:r>
             <a:r>
-              <a:rPr b="0" sz="1200">
+              <a:rPr sz="1600" b="0" dirty="0">
                 <a:solidFill>
                   <a:srgbClr val="282828"/>
                 </a:solidFill>
+                <a:latin typeface="Times New Roman" panose="02020603050405020304" pitchFamily="18" charset="0"/>
+                <a:cs typeface="Times New Roman" panose="02020603050405020304" pitchFamily="18" charset="0"/>
               </a:rPr>
-              <a:t>Drip irrigation generated significantly higher water productivity (Tonnes/1000m³) across all 3 agricultural seasons.</a:t>
+              <a:t>Drip irrigation generated significantly higher water productivity (</a:t>
+            </a:r>
+            <a:r>
+              <a:rPr sz="1600" b="0" dirty="0" err="1">
+                <a:solidFill>
+                  <a:srgbClr val="282828"/>
+                </a:solidFill>
+                <a:latin typeface="Times New Roman" panose="02020603050405020304" pitchFamily="18" charset="0"/>
+                <a:cs typeface="Times New Roman" panose="02020603050405020304" pitchFamily="18" charset="0"/>
+              </a:rPr>
+              <a:t>Tonnes</a:t>
+            </a:r>
+            <a:r>
+              <a:rPr sz="1600" b="0" dirty="0">
+                <a:solidFill>
+                  <a:srgbClr val="282828"/>
+                </a:solidFill>
+                <a:latin typeface="Times New Roman" panose="02020603050405020304" pitchFamily="18" charset="0"/>
+                <a:cs typeface="Times New Roman" panose="02020603050405020304" pitchFamily="18" charset="0"/>
+              </a:rPr>
+              <a:t>/1000m³) across all 3 agricultural seasons.</a:t>
             </a:r>
           </a:p>
           <a:p>
@@ -23475,18 +23355,22 @@
               </a:spcAft>
             </a:pPr>
             <a:r>
-              <a:rPr b="1" sz="1300">
+              <a:rPr sz="1600" b="1" dirty="0">
                 <a:solidFill>
                   <a:srgbClr val="102C57"/>
                 </a:solidFill>
+                <a:latin typeface="Times New Roman" panose="02020603050405020304" pitchFamily="18" charset="0"/>
+                <a:cs typeface="Times New Roman" panose="02020603050405020304" pitchFamily="18" charset="0"/>
               </a:rPr>
               <a:t>• Flood Irrigation Waste: </a:t>
             </a:r>
             <a:r>
-              <a:rPr b="0" sz="1200">
+              <a:rPr sz="1600" b="0" dirty="0">
                 <a:solidFill>
                   <a:srgbClr val="282828"/>
                 </a:solidFill>
+                <a:latin typeface="Times New Roman" panose="02020603050405020304" pitchFamily="18" charset="0"/>
+                <a:cs typeface="Times New Roman" panose="02020603050405020304" pitchFamily="18" charset="0"/>
               </a:rPr>
               <a:t>Traditional flood irrigation consumed the highest water volumes with the lowest marginal yield return.</a:t>
             </a:r>
@@ -23498,18 +23382,22 @@
               </a:spcAft>
             </a:pPr>
             <a:r>
-              <a:rPr b="1" sz="1300">
+              <a:rPr sz="1600" b="1" dirty="0">
                 <a:solidFill>
                   <a:srgbClr val="102C57"/>
                 </a:solidFill>
+                <a:latin typeface="Times New Roman" panose="02020603050405020304" pitchFamily="18" charset="0"/>
+                <a:cs typeface="Times New Roman" panose="02020603050405020304" pitchFamily="18" charset="0"/>
               </a:rPr>
               <a:t>• Correlation Findings: </a:t>
             </a:r>
             <a:r>
-              <a:rPr b="0" sz="1200">
+              <a:rPr sz="1600" b="0" dirty="0">
                 <a:solidFill>
                   <a:srgbClr val="282828"/>
                 </a:solidFill>
+                <a:latin typeface="Times New Roman" panose="02020603050405020304" pitchFamily="18" charset="0"/>
+                <a:cs typeface="Times New Roman" panose="02020603050405020304" pitchFamily="18" charset="0"/>
               </a:rPr>
               <a:t>Strong positive correlation observed between water efficiency, optimized fertilizer usage, and net farm revenue.</a:t>
             </a:r>
@@ -23841,121 +23729,6 @@
                       </p:childTnLst>
                     </p:cTn>
                   </p:par>
-                  <p:par>
-                    <p:cTn id="24" fill="hold">
-                      <p:stCondLst>
-                        <p:cond delay="indefinite"/>
-                      </p:stCondLst>
-                      <p:childTnLst>
-                        <p:par>
-                          <p:cTn id="25" fill="hold">
-                            <p:stCondLst>
-                              <p:cond delay="0"/>
-                            </p:stCondLst>
-                            <p:childTnLst>
-                              <p:par>
-                                <p:cTn id="26" presetID="42" presetClass="entr" presetSubtype="0" fill="hold" grpId="0" nodeType="clickEffect">
-                                  <p:stCondLst>
-                                    <p:cond delay="0"/>
-                                  </p:stCondLst>
-                                  <p:childTnLst>
-                                    <p:set>
-                                      <p:cBhvr>
-                                        <p:cTn id="27" dur="1" fill="hold">
-                                          <p:stCondLst>
-                                            <p:cond delay="0"/>
-                                          </p:stCondLst>
-                                        </p:cTn>
-                                        <p:tgtEl>
-                                          <p:spTgt spid="10">
-                                            <p:txEl>
-                                              <p:pRg st="0" end="0"/>
-                                            </p:txEl>
-                                          </p:spTgt>
-                                        </p:tgtEl>
-                                        <p:attrNameLst>
-                                          <p:attrName>style.visibility</p:attrName>
-                                        </p:attrNameLst>
-                                      </p:cBhvr>
-                                      <p:to>
-                                        <p:strVal val="visible"/>
-                                      </p:to>
-                                    </p:set>
-                                    <p:animEffect transition="in" filter="fade">
-                                      <p:cBhvr>
-                                        <p:cTn id="28" dur="1000"/>
-                                        <p:tgtEl>
-                                          <p:spTgt spid="10">
-                                            <p:txEl>
-                                              <p:pRg st="0" end="0"/>
-                                            </p:txEl>
-                                          </p:spTgt>
-                                        </p:tgtEl>
-                                      </p:cBhvr>
-                                    </p:animEffect>
-                                    <p:anim calcmode="lin" valueType="num">
-                                      <p:cBhvr>
-                                        <p:cTn id="29" dur="1000" fill="hold"/>
-                                        <p:tgtEl>
-                                          <p:spTgt spid="10">
-                                            <p:txEl>
-                                              <p:pRg st="0" end="0"/>
-                                            </p:txEl>
-                                          </p:spTgt>
-                                        </p:tgtEl>
-                                        <p:attrNameLst>
-                                          <p:attrName>ppt_x</p:attrName>
-                                        </p:attrNameLst>
-                                      </p:cBhvr>
-                                      <p:tavLst>
-                                        <p:tav tm="0">
-                                          <p:val>
-                                            <p:strVal val="#ppt_x"/>
-                                          </p:val>
-                                        </p:tav>
-                                        <p:tav tm="100000">
-                                          <p:val>
-                                            <p:strVal val="#ppt_x"/>
-                                          </p:val>
-                                        </p:tav>
-                                      </p:tavLst>
-                                    </p:anim>
-                                    <p:anim calcmode="lin" valueType="num">
-                                      <p:cBhvr>
-                                        <p:cTn id="30" dur="1000" fill="hold"/>
-                                        <p:tgtEl>
-                                          <p:spTgt spid="10">
-                                            <p:txEl>
-                                              <p:pRg st="0" end="0"/>
-                                            </p:txEl>
-                                          </p:spTgt>
-                                        </p:tgtEl>
-                                        <p:attrNameLst>
-                                          <p:attrName>ppt_y</p:attrName>
-                                        </p:attrNameLst>
-                                      </p:cBhvr>
-                                      <p:tavLst>
-                                        <p:tav tm="0">
-                                          <p:val>
-                                            <p:strVal val="#ppt_y+.1"/>
-                                          </p:val>
-                                        </p:tav>
-                                        <p:tav tm="100000">
-                                          <p:val>
-                                            <p:strVal val="#ppt_y"/>
-                                          </p:val>
-                                        </p:tav>
-                                      </p:tavLst>
-                                    </p:anim>
-                                  </p:childTnLst>
-                                </p:cTn>
-                              </p:par>
-                            </p:childTnLst>
-                          </p:cTn>
-                        </p:par>
-                      </p:childTnLst>
-                    </p:cTn>
-                  </p:par>
                 </p:childTnLst>
               </p:cTn>
               <p:prevCondLst>
@@ -23981,7 +23754,6 @@
       <p:bldP spid="4" grpId="0"/>
       <p:bldP spid="7" grpId="0"/>
       <p:bldP spid="8" grpId="0"/>
-      <p:bldP spid="10" grpId="0" build="p"/>
     </p:bldLst>
   </p:timing>
 </p:sld>
@@ -24835,6 +24607,15 @@
 </file>
 
 <file path=customXml/item1.xml><?xml version="1.0" encoding="utf-8"?>
+<p:properties xmlns:p="http://schemas.microsoft.com/office/2006/metadata/properties" xmlns:xsi="http://www.w3.org/2001/XMLSchema-instance" xmlns:pc="http://schemas.microsoft.com/office/infopath/2007/PartnerControls">
+  <documentManagement>
+    <Status xmlns="71af3243-3dd4-4a8d-8c0d-dd76da1f02a5">Not started</Status>
+    <MediaServiceKeyPoints xmlns="71af3243-3dd4-4a8d-8c0d-dd76da1f02a5" xsi:nil="true"/>
+  </documentManagement>
+</p:properties>
+</file>
+
+<file path=customXml/item2.xml><?xml version="1.0" encoding="utf-8"?>
 <ct:contentTypeSchema xmlns:ct="http://schemas.microsoft.com/office/2006/metadata/contentType" xmlns:ma="http://schemas.microsoft.com/office/2006/metadata/properties/metaAttributes" ct:_="" ma:_="" ma:contentTypeName="Document" ma:contentTypeID="0x01010079F111ED35F8CC479449609E8A0923A6" ma:contentTypeVersion="12" ma:contentTypeDescription="Create a new document." ma:contentTypeScope="" ma:versionID="426e97fa315356fffbdcd9876fe988c2">
   <xsd:schema xmlns:xsd="http://www.w3.org/2001/XMLSchema" xmlns:xs="http://www.w3.org/2001/XMLSchema" xmlns:p="http://schemas.microsoft.com/office/2006/metadata/properties" xmlns:ns2="71af3243-3dd4-4a8d-8c0d-dd76da1f02a5" xmlns:ns3="16c05727-aa75-4e4a-9b5f-8a80a1165891" targetNamespace="http://schemas.microsoft.com/office/2006/metadata/properties" ma:root="true" ma:fieldsID="14b8f0def80e6d70ce3def20c90759ae" ns2:_="" ns3:_="">
     <xsd:import namespace="71af3243-3dd4-4a8d-8c0d-dd76da1f02a5"/>
@@ -25055,15 +24836,6 @@
 </ct:contentTypeSchema>
 </file>
 
-<file path=customXml/item2.xml><?xml version="1.0" encoding="utf-8"?>
-<p:properties xmlns:p="http://schemas.microsoft.com/office/2006/metadata/properties" xmlns:xsi="http://www.w3.org/2001/XMLSchema-instance" xmlns:pc="http://schemas.microsoft.com/office/infopath/2007/PartnerControls">
-  <documentManagement>
-    <Status xmlns="71af3243-3dd4-4a8d-8c0d-dd76da1f02a5">Not started</Status>
-    <MediaServiceKeyPoints xmlns="71af3243-3dd4-4a8d-8c0d-dd76da1f02a5" xsi:nil="true"/>
-  </documentManagement>
-</p:properties>
-</file>
-
 <file path=customXml/item3.xml><?xml version="1.0" encoding="utf-8"?>
 <?mso-contentType ?>
 <FormTemplates xmlns="http://schemas.microsoft.com/sharepoint/v3/contenttype/forms">
@@ -25074,6 +24846,16 @@
 </file>
 
 <file path=customXml/itemProps1.xml><?xml version="1.0" encoding="utf-8"?>
+<ds:datastoreItem xmlns:ds="http://schemas.openxmlformats.org/officeDocument/2006/customXml" ds:itemID="{4DEA9014-ED64-4558-B1E1-D03F0EE32BEB}">
+  <ds:schemaRefs>
+    <ds:schemaRef ds:uri="http://schemas.microsoft.com/office/2006/metadata/properties"/>
+    <ds:schemaRef ds:uri="http://schemas.microsoft.com/office/infopath/2007/PartnerControls"/>
+    <ds:schemaRef ds:uri="71af3243-3dd4-4a8d-8c0d-dd76da1f02a5"/>
+  </ds:schemaRefs>
+</ds:datastoreItem>
+</file>
+
+<file path=customXml/itemProps2.xml><?xml version="1.0" encoding="utf-8"?>
 <ds:datastoreItem xmlns:ds="http://schemas.openxmlformats.org/officeDocument/2006/customXml" ds:itemID="{B19EB750-A6DA-4BE8-B87B-FC499FE73360}">
   <ds:schemaRefs>
     <ds:schemaRef ds:uri="http://schemas.microsoft.com/office/2006/metadata/contentType"/>
@@ -25092,16 +24874,6 @@
 </ds:datastoreItem>
 </file>
 
-<file path=customXml/itemProps2.xml><?xml version="1.0" encoding="utf-8"?>
-<ds:datastoreItem xmlns:ds="http://schemas.openxmlformats.org/officeDocument/2006/customXml" ds:itemID="{4DEA9014-ED64-4558-B1E1-D03F0EE32BEB}">
-  <ds:schemaRefs>
-    <ds:schemaRef ds:uri="http://schemas.microsoft.com/office/2006/metadata/properties"/>
-    <ds:schemaRef ds:uri="http://schemas.microsoft.com/office/infopath/2007/PartnerControls"/>
-    <ds:schemaRef ds:uri="71af3243-3dd4-4a8d-8c0d-dd76da1f02a5"/>
-  </ds:schemaRefs>
-</ds:datastoreItem>
-</file>
-
 <file path=customXml/itemProps3.xml><?xml version="1.0" encoding="utf-8"?>
 <ds:datastoreItem xmlns:ds="http://schemas.openxmlformats.org/officeDocument/2006/customXml" ds:itemID="{05D99ABA-76CE-4A8E-B5F0-C051B96628DE}">
   <ds:schemaRefs>

</xml_diff>